<commit_message>
Actualització del Sprint Review
</commit_message>
<xml_diff>
--- a/Documents/Sprint_Reviews/Sprint_Review01.pptx
+++ b/Documents/Sprint_Reviews/Sprint_Review01.pptx
@@ -822,7 +822,7 @@
   <p:cSld>
     <p:spTree>
       <p:nvGrpSpPr>
-        <p:cNvPr id="170" name="Shape 170"/>
+        <p:cNvPr id="173" name="Shape 173"/>
         <p:cNvGrpSpPr/>
         <p:nvPr/>
       </p:nvGrpSpPr>
@@ -836,7 +836,7 @@
       </p:grpSpPr>
       <p:sp>
         <p:nvSpPr>
-          <p:cNvPr id="171" name="Google Shape;171;g396060f51c5_0_26:notes"/>
+          <p:cNvPr id="174" name="Google Shape;174;g396060f51c5_0_26:notes"/>
           <p:cNvSpPr/>
           <p:nvPr>
             <p:ph idx="2" type="sldImg"/>
@@ -871,7 +871,7 @@
       </p:sp>
       <p:sp>
         <p:nvSpPr>
-          <p:cNvPr id="172" name="Google Shape;172;g396060f51c5_0_26:notes"/>
+          <p:cNvPr id="175" name="Google Shape;175;g396060f51c5_0_26:notes"/>
           <p:cNvSpPr txBox="1"/>
           <p:nvPr>
             <p:ph idx="1" type="body"/>
@@ -921,7 +921,7 @@
   <p:cSld>
     <p:spTree>
       <p:nvGrpSpPr>
-        <p:cNvPr id="176" name="Shape 176"/>
+        <p:cNvPr id="179" name="Shape 179"/>
         <p:cNvGrpSpPr/>
         <p:nvPr/>
       </p:nvGrpSpPr>
@@ -935,7 +935,7 @@
       </p:grpSpPr>
       <p:sp>
         <p:nvSpPr>
-          <p:cNvPr id="177" name="Google Shape;177;g396060f51c5_0_31:notes"/>
+          <p:cNvPr id="180" name="Google Shape;180;g396060f51c5_0_31:notes"/>
           <p:cNvSpPr/>
           <p:nvPr>
             <p:ph idx="2" type="sldImg"/>
@@ -970,7 +970,7 @@
       </p:sp>
       <p:sp>
         <p:nvSpPr>
-          <p:cNvPr id="178" name="Google Shape;178;g396060f51c5_0_31:notes"/>
+          <p:cNvPr id="181" name="Google Shape;181;g396060f51c5_0_31:notes"/>
           <p:cNvSpPr txBox="1"/>
           <p:nvPr>
             <p:ph idx="1" type="body"/>
@@ -1020,7 +1020,7 @@
   <p:cSld>
     <p:spTree>
       <p:nvGrpSpPr>
-        <p:cNvPr id="182" name="Shape 182"/>
+        <p:cNvPr id="185" name="Shape 185"/>
         <p:cNvGrpSpPr/>
         <p:nvPr/>
       </p:nvGrpSpPr>
@@ -1034,7 +1034,7 @@
       </p:grpSpPr>
       <p:sp>
         <p:nvSpPr>
-          <p:cNvPr id="183" name="Google Shape;183;g3cf70ef3b9e_0_30:notes"/>
+          <p:cNvPr id="186" name="Google Shape;186;g3cf70ef3b9e_0_30:notes"/>
           <p:cNvSpPr/>
           <p:nvPr>
             <p:ph idx="2" type="sldImg"/>
@@ -1069,7 +1069,7 @@
       </p:sp>
       <p:sp>
         <p:nvSpPr>
-          <p:cNvPr id="184" name="Google Shape;184;g3cf70ef3b9e_0_30:notes"/>
+          <p:cNvPr id="187" name="Google Shape;187;g3cf70ef3b9e_0_30:notes"/>
           <p:cNvSpPr txBox="1"/>
           <p:nvPr>
             <p:ph idx="1" type="body"/>
@@ -1218,7 +1218,7 @@
   <p:cSld>
     <p:spTree>
       <p:nvGrpSpPr>
-        <p:cNvPr id="112" name="Shape 112"/>
+        <p:cNvPr id="113" name="Shape 113"/>
         <p:cNvGrpSpPr/>
         <p:nvPr/>
       </p:nvGrpSpPr>
@@ -1232,7 +1232,7 @@
       </p:grpSpPr>
       <p:sp>
         <p:nvSpPr>
-          <p:cNvPr id="113" name="Google Shape;113;g3cf70ef3b9e_0_10:notes"/>
+          <p:cNvPr id="114" name="Google Shape;114;g3cf70ef3b9e_0_10:notes"/>
           <p:cNvSpPr/>
           <p:nvPr>
             <p:ph idx="2" type="sldImg"/>
@@ -1267,7 +1267,7 @@
       </p:sp>
       <p:sp>
         <p:nvSpPr>
-          <p:cNvPr id="114" name="Google Shape;114;g3cf70ef3b9e_0_10:notes"/>
+          <p:cNvPr id="115" name="Google Shape;115;g3cf70ef3b9e_0_10:notes"/>
           <p:cNvSpPr txBox="1"/>
           <p:nvPr>
             <p:ph idx="1" type="body"/>
@@ -1317,7 +1317,7 @@
   <p:cSld>
     <p:spTree>
       <p:nvGrpSpPr>
-        <p:cNvPr id="123" name="Shape 123"/>
+        <p:cNvPr id="126" name="Shape 126"/>
         <p:cNvGrpSpPr/>
         <p:nvPr/>
       </p:nvGrpSpPr>
@@ -1331,7 +1331,7 @@
       </p:grpSpPr>
       <p:sp>
         <p:nvSpPr>
-          <p:cNvPr id="124" name="Google Shape;124;g3d02b607959_0_2:notes"/>
+          <p:cNvPr id="127" name="Google Shape;127;g3d02b607959_0_2:notes"/>
           <p:cNvSpPr/>
           <p:nvPr>
             <p:ph idx="2" type="sldImg"/>
@@ -1366,7 +1366,7 @@
       </p:sp>
       <p:sp>
         <p:nvSpPr>
-          <p:cNvPr id="125" name="Google Shape;125;g3d02b607959_0_2:notes"/>
+          <p:cNvPr id="128" name="Google Shape;128;g3d02b607959_0_2:notes"/>
           <p:cNvSpPr txBox="1"/>
           <p:nvPr>
             <p:ph idx="1" type="body"/>
@@ -1416,7 +1416,7 @@
   <p:cSld>
     <p:spTree>
       <p:nvGrpSpPr>
-        <p:cNvPr id="140" name="Shape 140"/>
+        <p:cNvPr id="143" name="Shape 143"/>
         <p:cNvGrpSpPr/>
         <p:nvPr/>
       </p:nvGrpSpPr>
@@ -1430,7 +1430,7 @@
       </p:grpSpPr>
       <p:sp>
         <p:nvSpPr>
-          <p:cNvPr id="141" name="Google Shape;141;g3cf70ef3b9e_0_26:notes"/>
+          <p:cNvPr id="144" name="Google Shape;144;g3cf70ef3b9e_0_26:notes"/>
           <p:cNvSpPr/>
           <p:nvPr>
             <p:ph idx="2" type="sldImg"/>
@@ -1465,7 +1465,7 @@
       </p:sp>
       <p:sp>
         <p:nvSpPr>
-          <p:cNvPr id="142" name="Google Shape;142;g3cf70ef3b9e_0_26:notes"/>
+          <p:cNvPr id="145" name="Google Shape;145;g3cf70ef3b9e_0_26:notes"/>
           <p:cNvSpPr txBox="1"/>
           <p:nvPr>
             <p:ph idx="1" type="body"/>
@@ -1515,7 +1515,7 @@
   <p:cSld>
     <p:spTree>
       <p:nvGrpSpPr>
-        <p:cNvPr id="146" name="Shape 146"/>
+        <p:cNvPr id="149" name="Shape 149"/>
         <p:cNvGrpSpPr/>
         <p:nvPr/>
       </p:nvGrpSpPr>
@@ -1529,7 +1529,7 @@
       </p:grpSpPr>
       <p:sp>
         <p:nvSpPr>
-          <p:cNvPr id="147" name="Google Shape;147;g396060f51c5_0_1:notes"/>
+          <p:cNvPr id="150" name="Google Shape;150;g396060f51c5_0_1:notes"/>
           <p:cNvSpPr/>
           <p:nvPr>
             <p:ph idx="2" type="sldImg"/>
@@ -1564,7 +1564,7 @@
       </p:sp>
       <p:sp>
         <p:nvSpPr>
-          <p:cNvPr id="148" name="Google Shape;148;g396060f51c5_0_1:notes"/>
+          <p:cNvPr id="151" name="Google Shape;151;g396060f51c5_0_1:notes"/>
           <p:cNvSpPr txBox="1"/>
           <p:nvPr>
             <p:ph idx="1" type="body"/>
@@ -1614,7 +1614,7 @@
   <p:cSld>
     <p:spTree>
       <p:nvGrpSpPr>
-        <p:cNvPr id="152" name="Shape 152"/>
+        <p:cNvPr id="155" name="Shape 155"/>
         <p:cNvGrpSpPr/>
         <p:nvPr/>
       </p:nvGrpSpPr>
@@ -1628,7 +1628,7 @@
       </p:grpSpPr>
       <p:sp>
         <p:nvSpPr>
-          <p:cNvPr id="153" name="Google Shape;153;g396060f51c5_0_6:notes"/>
+          <p:cNvPr id="156" name="Google Shape;156;g396060f51c5_0_6:notes"/>
           <p:cNvSpPr/>
           <p:nvPr>
             <p:ph idx="2" type="sldImg"/>
@@ -1663,7 +1663,7 @@
       </p:sp>
       <p:sp>
         <p:nvSpPr>
-          <p:cNvPr id="154" name="Google Shape;154;g396060f51c5_0_6:notes"/>
+          <p:cNvPr id="157" name="Google Shape;157;g396060f51c5_0_6:notes"/>
           <p:cNvSpPr txBox="1"/>
           <p:nvPr>
             <p:ph idx="1" type="body"/>
@@ -1713,7 +1713,7 @@
   <p:cSld>
     <p:spTree>
       <p:nvGrpSpPr>
-        <p:cNvPr id="158" name="Shape 158"/>
+        <p:cNvPr id="161" name="Shape 161"/>
         <p:cNvGrpSpPr/>
         <p:nvPr/>
       </p:nvGrpSpPr>
@@ -1727,7 +1727,7 @@
       </p:grpSpPr>
       <p:sp>
         <p:nvSpPr>
-          <p:cNvPr id="159" name="Google Shape;159;g396060f51c5_0_11:notes"/>
+          <p:cNvPr id="162" name="Google Shape;162;g396060f51c5_0_11:notes"/>
           <p:cNvSpPr/>
           <p:nvPr>
             <p:ph idx="2" type="sldImg"/>
@@ -1762,7 +1762,7 @@
       </p:sp>
       <p:sp>
         <p:nvSpPr>
-          <p:cNvPr id="160" name="Google Shape;160;g396060f51c5_0_11:notes"/>
+          <p:cNvPr id="163" name="Google Shape;163;g396060f51c5_0_11:notes"/>
           <p:cNvSpPr txBox="1"/>
           <p:nvPr>
             <p:ph idx="1" type="body"/>
@@ -1812,7 +1812,7 @@
   <p:cSld>
     <p:spTree>
       <p:nvGrpSpPr>
-        <p:cNvPr id="164" name="Shape 164"/>
+        <p:cNvPr id="167" name="Shape 167"/>
         <p:cNvGrpSpPr/>
         <p:nvPr/>
       </p:nvGrpSpPr>
@@ -1826,7 +1826,7 @@
       </p:grpSpPr>
       <p:sp>
         <p:nvSpPr>
-          <p:cNvPr id="165" name="Google Shape;165;g396060f51c5_0_16:notes"/>
+          <p:cNvPr id="168" name="Google Shape;168;g396060f51c5_0_16:notes"/>
           <p:cNvSpPr/>
           <p:nvPr>
             <p:ph idx="2" type="sldImg"/>
@@ -1861,7 +1861,7 @@
       </p:sp>
       <p:sp>
         <p:nvSpPr>
-          <p:cNvPr id="166" name="Google Shape;166;g396060f51c5_0_16:notes"/>
+          <p:cNvPr id="169" name="Google Shape;169;g396060f51c5_0_16:notes"/>
           <p:cNvSpPr txBox="1"/>
           <p:nvPr>
             <p:ph idx="1" type="body"/>
@@ -13095,7 +13095,7 @@
   <p:cSld>
     <p:spTree>
       <p:nvGrpSpPr>
-        <p:cNvPr id="173" name="Shape 173"/>
+        <p:cNvPr id="176" name="Shape 176"/>
         <p:cNvGrpSpPr/>
         <p:nvPr/>
       </p:nvGrpSpPr>
@@ -13109,7 +13109,7 @@
       </p:grpSpPr>
       <p:sp>
         <p:nvSpPr>
-          <p:cNvPr id="174" name="Google Shape;174;p30"/>
+          <p:cNvPr id="177" name="Google Shape;177;p30"/>
           <p:cNvSpPr txBox="1"/>
           <p:nvPr>
             <p:ph type="title"/>
@@ -13149,7 +13149,7 @@
       </p:sp>
       <p:sp>
         <p:nvSpPr>
-          <p:cNvPr id="175" name="Google Shape;175;p30"/>
+          <p:cNvPr id="178" name="Google Shape;178;p30"/>
           <p:cNvSpPr txBox="1"/>
           <p:nvPr/>
         </p:nvSpPr>
@@ -13291,12 +13291,20 @@
               <a:buNone/>
             </a:pPr>
             <a:r>
+              <a:rPr b="1" lang="en" u="sng">
+                <a:solidFill>
+                  <a:schemeClr val="dk1"/>
+                </a:solidFill>
+              </a:rPr>
+              <a:t>RNF 37</a:t>
+            </a:r>
+            <a:r>
               <a:rPr b="1" lang="en">
                 <a:solidFill>
                   <a:schemeClr val="dk1"/>
                 </a:solidFill>
               </a:rPr>
-              <a:t>RNF 37: </a:t>
+              <a:t>: </a:t>
             </a:r>
             <a:r>
               <a:rPr lang="en">
@@ -13304,7 +13312,23 @@
                   <a:schemeClr val="dk1"/>
                 </a:solidFill>
               </a:rPr>
-              <a:t>Només els cuiners poden accedir al menú especific.(RNF de Restricció de Disseny, seguretat). </a:t>
+              <a:t>Només els cuiners poden accedir al menú especific.(RNF de </a:t>
+            </a:r>
+            <a:r>
+              <a:rPr lang="en" u="sng">
+                <a:solidFill>
+                  <a:schemeClr val="dk1"/>
+                </a:solidFill>
+              </a:rPr>
+              <a:t>Restricció de Disseny, seguretat</a:t>
+            </a:r>
+            <a:r>
+              <a:rPr lang="en">
+                <a:solidFill>
+                  <a:schemeClr val="dk1"/>
+                </a:solidFill>
+              </a:rPr>
+              <a:t>). </a:t>
             </a:r>
             <a:endParaRPr>
               <a:solidFill>
@@ -13432,7 +13456,7 @@
   <p:cSld>
     <p:spTree>
       <p:nvGrpSpPr>
-        <p:cNvPr id="179" name="Shape 179"/>
+        <p:cNvPr id="182" name="Shape 182"/>
         <p:cNvGrpSpPr/>
         <p:nvPr/>
       </p:nvGrpSpPr>
@@ -13446,7 +13470,7 @@
       </p:grpSpPr>
       <p:sp>
         <p:nvSpPr>
-          <p:cNvPr id="180" name="Google Shape;180;p31"/>
+          <p:cNvPr id="183" name="Google Shape;183;p31"/>
           <p:cNvSpPr txBox="1"/>
           <p:nvPr>
             <p:ph type="title"/>
@@ -13486,7 +13510,7 @@
       </p:sp>
       <p:sp>
         <p:nvSpPr>
-          <p:cNvPr id="181" name="Google Shape;181;p31"/>
+          <p:cNvPr id="184" name="Google Shape;184;p31"/>
           <p:cNvSpPr txBox="1"/>
           <p:nvPr/>
         </p:nvSpPr>
@@ -13571,12 +13595,20 @@
               <a:buNone/>
             </a:pPr>
             <a:r>
+              <a:rPr b="1" lang="en" u="sng">
+                <a:solidFill>
+                  <a:schemeClr val="dk1"/>
+                </a:solidFill>
+              </a:rPr>
+              <a:t>RNF 41</a:t>
+            </a:r>
+            <a:r>
               <a:rPr b="1" lang="en">
                 <a:solidFill>
                   <a:schemeClr val="dk1"/>
                 </a:solidFill>
               </a:rPr>
-              <a:t>RNF 41: </a:t>
+              <a:t>: </a:t>
             </a:r>
             <a:r>
               <a:rPr lang="en">
@@ -13584,7 +13616,23 @@
                   <a:schemeClr val="dk1"/>
                 </a:solidFill>
               </a:rPr>
-              <a:t>Es farà servir a l'àrea metropolitana de Barcelona (RNF de Restricció de Disseny).</a:t>
+              <a:t>Es farà servir a l'àrea metropolitana de Barcelona (RNF de </a:t>
+            </a:r>
+            <a:r>
+              <a:rPr lang="en" u="sng">
+                <a:solidFill>
+                  <a:schemeClr val="dk1"/>
+                </a:solidFill>
+              </a:rPr>
+              <a:t>Restricció de Disseny</a:t>
+            </a:r>
+            <a:r>
+              <a:rPr lang="en">
+                <a:solidFill>
+                  <a:schemeClr val="dk1"/>
+                </a:solidFill>
+              </a:rPr>
+              <a:t>).</a:t>
             </a:r>
             <a:endParaRPr>
               <a:solidFill>
@@ -13606,12 +13654,20 @@
               <a:buNone/>
             </a:pPr>
             <a:r>
+              <a:rPr b="1" lang="en" u="sng">
+                <a:solidFill>
+                  <a:schemeClr val="dk1"/>
+                </a:solidFill>
+              </a:rPr>
+              <a:t>RNF 42</a:t>
+            </a:r>
+            <a:r>
               <a:rPr b="1" lang="en">
                 <a:solidFill>
                   <a:schemeClr val="dk1"/>
                 </a:solidFill>
               </a:rPr>
-              <a:t>RNF 42: </a:t>
+              <a:t>: </a:t>
             </a:r>
             <a:r>
               <a:rPr lang="en">
@@ -13619,7 +13675,23 @@
                   <a:schemeClr val="dk1"/>
                 </a:solidFill>
               </a:rPr>
-              <a:t>La interfície serà trilingüe: Espanyol, Català i Anglès (RNF d’Interfícies Externes). </a:t>
+              <a:t>La interfície serà trilingüe: Espanyol, Català i Anglès (RNF </a:t>
+            </a:r>
+            <a:r>
+              <a:rPr lang="en" u="sng">
+                <a:solidFill>
+                  <a:schemeClr val="dk1"/>
+                </a:solidFill>
+              </a:rPr>
+              <a:t>d’Interfícies Externes</a:t>
+            </a:r>
+            <a:r>
+              <a:rPr lang="en">
+                <a:solidFill>
+                  <a:schemeClr val="dk1"/>
+                </a:solidFill>
+              </a:rPr>
+              <a:t>). </a:t>
             </a:r>
             <a:endParaRPr>
               <a:solidFill>
@@ -13641,12 +13713,20 @@
               <a:buNone/>
             </a:pPr>
             <a:r>
+              <a:rPr b="1" lang="en" u="sng">
+                <a:solidFill>
+                  <a:schemeClr val="dk1"/>
+                </a:solidFill>
+              </a:rPr>
+              <a:t>RNF 43</a:t>
+            </a:r>
+            <a:r>
               <a:rPr b="1" lang="en">
                 <a:solidFill>
                   <a:schemeClr val="dk1"/>
                 </a:solidFill>
               </a:rPr>
-              <a:t>RNF 43: </a:t>
+              <a:t>: </a:t>
             </a:r>
             <a:r>
               <a:rPr lang="en">
@@ -13654,7 +13734,23 @@
                   <a:schemeClr val="dk1"/>
                 </a:solidFill>
               </a:rPr>
-              <a:t>Apte tant per a Web com per a Mòbil (RNF d’Interfícies Externes). </a:t>
+              <a:t>Apte tant per a Web com per a Mòbil (RNF </a:t>
+            </a:r>
+            <a:r>
+              <a:rPr lang="en" u="sng">
+                <a:solidFill>
+                  <a:schemeClr val="dk1"/>
+                </a:solidFill>
+              </a:rPr>
+              <a:t>d’Interfícies Externes</a:t>
+            </a:r>
+            <a:r>
+              <a:rPr lang="en">
+                <a:solidFill>
+                  <a:schemeClr val="dk1"/>
+                </a:solidFill>
+              </a:rPr>
+              <a:t>). </a:t>
             </a:r>
             <a:endParaRPr>
               <a:solidFill>
@@ -13676,12 +13772,20 @@
               <a:buNone/>
             </a:pPr>
             <a:r>
+              <a:rPr b="1" lang="en" u="sng">
+                <a:solidFill>
+                  <a:schemeClr val="dk1"/>
+                </a:solidFill>
+              </a:rPr>
+              <a:t>RNF 44</a:t>
+            </a:r>
+            <a:r>
               <a:rPr b="1" lang="en">
                 <a:solidFill>
                   <a:schemeClr val="dk1"/>
                 </a:solidFill>
               </a:rPr>
-              <a:t>RNF 44: </a:t>
+              <a:t>: </a:t>
             </a:r>
             <a:r>
               <a:rPr lang="en">
@@ -13689,7 +13793,23 @@
                   <a:schemeClr val="dk1"/>
                 </a:solidFill>
               </a:rPr>
-              <a:t>Els Mòbils hauran de tenir sistema operatiu IOS o Android (RNF de Restricció de Disseny, limitació de Hw). </a:t>
+              <a:t>Els Mòbils hauran de tenir sistema operatiu IOS o Android (RNF de </a:t>
+            </a:r>
+            <a:r>
+              <a:rPr lang="en" u="sng">
+                <a:solidFill>
+                  <a:schemeClr val="dk1"/>
+                </a:solidFill>
+              </a:rPr>
+              <a:t>Restricció de Disseny, limitació de Hw</a:t>
+            </a:r>
+            <a:r>
+              <a:rPr lang="en">
+                <a:solidFill>
+                  <a:schemeClr val="dk1"/>
+                </a:solidFill>
+              </a:rPr>
+              <a:t>). </a:t>
             </a:r>
             <a:endParaRPr>
               <a:solidFill>
@@ -13711,12 +13831,20 @@
               <a:buNone/>
             </a:pPr>
             <a:r>
+              <a:rPr b="1" lang="en" u="sng">
+                <a:solidFill>
+                  <a:schemeClr val="dk1"/>
+                </a:solidFill>
+              </a:rPr>
+              <a:t>RNF 45</a:t>
+            </a:r>
+            <a:r>
               <a:rPr b="1" lang="en">
                 <a:solidFill>
                   <a:schemeClr val="dk1"/>
                 </a:solidFill>
               </a:rPr>
-              <a:t>RNF 45: </a:t>
+              <a:t>: </a:t>
             </a:r>
             <a:r>
               <a:rPr lang="en">
@@ -13724,7 +13852,23 @@
                   <a:schemeClr val="dk1"/>
                 </a:solidFill>
               </a:rPr>
-              <a:t>Lletra Calibri tant a encapçalaments com per a la resta de continguts. (RNF d’Interfícies Externes). </a:t>
+              <a:t>Lletra Calibri tant a encapçalaments com per a la resta de continguts. (RNF </a:t>
+            </a:r>
+            <a:r>
+              <a:rPr lang="en" u="sng">
+                <a:solidFill>
+                  <a:schemeClr val="dk1"/>
+                </a:solidFill>
+              </a:rPr>
+              <a:t>d’Interfícies Externes</a:t>
+            </a:r>
+            <a:r>
+              <a:rPr lang="en">
+                <a:solidFill>
+                  <a:schemeClr val="dk1"/>
+                </a:solidFill>
+              </a:rPr>
+              <a:t>). </a:t>
             </a:r>
             <a:endParaRPr>
               <a:solidFill>
@@ -13746,12 +13890,20 @@
               <a:buNone/>
             </a:pPr>
             <a:r>
+              <a:rPr b="1" lang="en" u="sng">
+                <a:solidFill>
+                  <a:schemeClr val="dk1"/>
+                </a:solidFill>
+              </a:rPr>
+              <a:t>RNF 46</a:t>
+            </a:r>
+            <a:r>
               <a:rPr b="1" lang="en">
                 <a:solidFill>
                   <a:schemeClr val="dk1"/>
                 </a:solidFill>
               </a:rPr>
-              <a:t>RNF 46: </a:t>
+              <a:t>: </a:t>
             </a:r>
             <a:r>
               <a:rPr lang="en">
@@ -13759,7 +13911,23 @@
                   <a:schemeClr val="dk1"/>
                 </a:solidFill>
               </a:rPr>
-              <a:t>Color corporatiu taronja i  El logo ha d'aparèixer a totes les pantalles. (RNF d’Interfícies Externes). </a:t>
+              <a:t>Color corporatiu taronja i  El logo ha d'aparèixer a totes les pantalles. (RNF </a:t>
+            </a:r>
+            <a:r>
+              <a:rPr lang="en" u="sng">
+                <a:solidFill>
+                  <a:schemeClr val="dk1"/>
+                </a:solidFill>
+              </a:rPr>
+              <a:t>d’Interfícies Externes</a:t>
+            </a:r>
+            <a:r>
+              <a:rPr lang="en">
+                <a:solidFill>
+                  <a:schemeClr val="dk1"/>
+                </a:solidFill>
+              </a:rPr>
+              <a:t>). </a:t>
             </a:r>
             <a:endParaRPr>
               <a:solidFill>
@@ -13781,12 +13949,20 @@
               <a:buNone/>
             </a:pPr>
             <a:r>
+              <a:rPr b="1" lang="en" u="sng">
+                <a:solidFill>
+                  <a:schemeClr val="dk1"/>
+                </a:solidFill>
+              </a:rPr>
+              <a:t>RNF 47</a:t>
+            </a:r>
+            <a:r>
               <a:rPr b="1" lang="en">
                 <a:solidFill>
                   <a:schemeClr val="dk1"/>
                 </a:solidFill>
               </a:rPr>
-              <a:t>RNF 47: </a:t>
+              <a:t>: </a:t>
             </a:r>
             <a:r>
               <a:rPr lang="en">
@@ -13794,7 +13970,23 @@
                   <a:schemeClr val="dk1"/>
                 </a:solidFill>
               </a:rPr>
-              <a:t>La app ha de suportar 1000 usuaris connectats alhora (RNF de Rendiment estàtic).</a:t>
+              <a:t>La app ha de suportar 1000 usuaris connectats alhora (RNF de </a:t>
+            </a:r>
+            <a:r>
+              <a:rPr lang="en" u="sng">
+                <a:solidFill>
+                  <a:schemeClr val="dk1"/>
+                </a:solidFill>
+              </a:rPr>
+              <a:t>Rendiment estàtic</a:t>
+            </a:r>
+            <a:r>
+              <a:rPr lang="en">
+                <a:solidFill>
+                  <a:schemeClr val="dk1"/>
+                </a:solidFill>
+              </a:rPr>
+              <a:t>).</a:t>
             </a:r>
             <a:endParaRPr>
               <a:solidFill>
@@ -13816,12 +14008,20 @@
               <a:buNone/>
             </a:pPr>
             <a:r>
+              <a:rPr b="1" lang="en" u="sng">
+                <a:solidFill>
+                  <a:schemeClr val="dk1"/>
+                </a:solidFill>
+              </a:rPr>
+              <a:t>RNF 48</a:t>
+            </a:r>
+            <a:r>
               <a:rPr b="1" lang="en">
                 <a:solidFill>
                   <a:schemeClr val="dk1"/>
                 </a:solidFill>
               </a:rPr>
-              <a:t>RNF 48: </a:t>
+              <a:t>: </a:t>
             </a:r>
             <a:r>
               <a:rPr lang="en">
@@ -13829,7 +14029,23 @@
                   <a:schemeClr val="dk1"/>
                 </a:solidFill>
               </a:rPr>
-              <a:t>El temps màxim de resposta de la app ha de ser de 5 milisegons (RNF de Rendiment dinàmic).</a:t>
+              <a:t>El temps màxim de resposta de la app ha de ser de 5 milisegons (RNF de </a:t>
+            </a:r>
+            <a:r>
+              <a:rPr lang="en" u="sng">
+                <a:solidFill>
+                  <a:schemeClr val="dk1"/>
+                </a:solidFill>
+              </a:rPr>
+              <a:t>Rendiment dinàmic</a:t>
+            </a:r>
+            <a:r>
+              <a:rPr lang="en">
+                <a:solidFill>
+                  <a:schemeClr val="dk1"/>
+                </a:solidFill>
+              </a:rPr>
+              <a:t>).</a:t>
             </a:r>
             <a:endParaRPr>
               <a:solidFill>
@@ -13851,12 +14067,20 @@
               <a:buNone/>
             </a:pPr>
             <a:r>
+              <a:rPr b="1" lang="en" u="sng">
+                <a:solidFill>
+                  <a:schemeClr val="dk1"/>
+                </a:solidFill>
+              </a:rPr>
+              <a:t>RNF 49</a:t>
+            </a:r>
+            <a:r>
               <a:rPr b="1" lang="en">
                 <a:solidFill>
                   <a:schemeClr val="dk1"/>
                 </a:solidFill>
               </a:rPr>
-              <a:t>RNF 49:</a:t>
+              <a:t>:</a:t>
             </a:r>
             <a:r>
               <a:rPr lang="en">
@@ -13864,7 +14088,23 @@
                   <a:schemeClr val="dk1"/>
                 </a:solidFill>
               </a:rPr>
-              <a:t> Per a encriptar dades es farà servir el protocol OpenVPN (RNF de Decisió de Disseny).</a:t>
+              <a:t> Per a encriptar dades es farà servir el protocol OpenVPN (RNF de </a:t>
+            </a:r>
+            <a:r>
+              <a:rPr lang="en" u="sng">
+                <a:solidFill>
+                  <a:schemeClr val="dk1"/>
+                </a:solidFill>
+              </a:rPr>
+              <a:t>Decisió de Disseny</a:t>
+            </a:r>
+            <a:r>
+              <a:rPr lang="en">
+                <a:solidFill>
+                  <a:schemeClr val="dk1"/>
+                </a:solidFill>
+              </a:rPr>
+              <a:t>).</a:t>
             </a:r>
             <a:endParaRPr>
               <a:solidFill>
@@ -13886,12 +14126,20 @@
               <a:buNone/>
             </a:pPr>
             <a:r>
+              <a:rPr b="1" lang="en" u="sng">
+                <a:solidFill>
+                  <a:schemeClr val="dk1"/>
+                </a:solidFill>
+              </a:rPr>
+              <a:t>RNF 50</a:t>
+            </a:r>
+            <a:r>
               <a:rPr b="1" lang="en">
                 <a:solidFill>
                   <a:schemeClr val="dk1"/>
                 </a:solidFill>
               </a:rPr>
-              <a:t>RNF 50: </a:t>
+              <a:t>: </a:t>
             </a:r>
             <a:r>
               <a:rPr lang="en">
@@ -13899,7 +14147,15 @@
                   <a:schemeClr val="dk1"/>
                 </a:solidFill>
               </a:rPr>
-              <a:t>Interfície amigable i responsive. (RNF d'Objectius de Disseny</a:t>
+              <a:t>Interfície amigable i responsive. (RNF </a:t>
+            </a:r>
+            <a:r>
+              <a:rPr lang="en" u="sng">
+                <a:solidFill>
+                  <a:schemeClr val="dk1"/>
+                </a:solidFill>
+              </a:rPr>
+              <a:t>d'Objectius de Disseny</a:t>
             </a:r>
             <a:r>
               <a:rPr b="1" lang="en">
@@ -13952,7 +14208,7 @@
   <p:cSld>
     <p:spTree>
       <p:nvGrpSpPr>
-        <p:cNvPr id="185" name="Shape 185"/>
+        <p:cNvPr id="188" name="Shape 188"/>
         <p:cNvGrpSpPr/>
         <p:nvPr/>
       </p:nvGrpSpPr>
@@ -13966,7 +14222,7 @@
       </p:grpSpPr>
       <p:sp>
         <p:nvSpPr>
-          <p:cNvPr id="186" name="Google Shape;186;p32"/>
+          <p:cNvPr id="189" name="Google Shape;189;p32"/>
           <p:cNvSpPr txBox="1"/>
           <p:nvPr>
             <p:ph type="title"/>
@@ -14006,7 +14262,7 @@
       </p:sp>
       <p:pic>
         <p:nvPicPr>
-          <p:cNvPr id="187" name="Google Shape;187;p32"/>
+          <p:cNvPr id="190" name="Google Shape;190;p32"/>
           <p:cNvPicPr preferRelativeResize="0"/>
           <p:nvPr/>
         </p:nvPicPr>
@@ -14034,7 +14290,7 @@
       </p:pic>
       <p:pic>
         <p:nvPicPr>
-          <p:cNvPr id="188" name="Google Shape;188;p32"/>
+          <p:cNvPr id="191" name="Google Shape;191;p32"/>
           <p:cNvPicPr preferRelativeResize="0"/>
           <p:nvPr/>
         </p:nvPicPr>
@@ -14349,8 +14605,8 @@
         </p:blipFill>
         <p:spPr>
           <a:xfrm>
-            <a:off x="4887524" y="2257723"/>
-            <a:ext cx="1068149" cy="1068149"/>
+            <a:off x="1579763" y="2275875"/>
+            <a:ext cx="1031826" cy="1031826"/>
           </a:xfrm>
           <a:prstGeom prst="rect">
             <a:avLst/>
@@ -14363,22 +14619,21 @@
       </p:pic>
       <p:pic>
         <p:nvPicPr>
-          <p:cNvPr id="110" name="Google Shape;110;p22"/>
+          <p:cNvPr id="110" name="Google Shape;110;p22" title="IMG-20250713-WA0003.jpg"/>
           <p:cNvPicPr preferRelativeResize="0"/>
           <p:nvPr/>
         </p:nvPicPr>
-        <p:blipFill>
+        <p:blipFill rotWithShape="1">
           <a:blip r:embed="rId5">
             <a:alphaModFix/>
           </a:blip>
-          <a:stretch>
-            <a:fillRect/>
-          </a:stretch>
+          <a:srcRect b="41890" l="20975" r="52416" t="38154"/>
+          <a:stretch/>
         </p:blipFill>
         <p:spPr>
           <a:xfrm>
-            <a:off x="6514275" y="2275876"/>
-            <a:ext cx="1068150" cy="1031829"/>
+            <a:off x="3260775" y="2257725"/>
+            <a:ext cx="1068150" cy="1068152"/>
           </a:xfrm>
           <a:prstGeom prst="rect">
             <a:avLst/>
@@ -14391,22 +14646,48 @@
       </p:pic>
       <p:pic>
         <p:nvPicPr>
-          <p:cNvPr id="111" name="Google Shape;111;p22"/>
+          <p:cNvPr id="111" name="Google Shape;111;p22" title="WhatsApp Image 2026-03-15 at 17.03.54.jpeg"/>
           <p:cNvPicPr preferRelativeResize="0"/>
           <p:nvPr/>
         </p:nvPicPr>
-        <p:blipFill>
+        <p:blipFill rotWithShape="1">
           <a:blip r:embed="rId6">
             <a:alphaModFix/>
           </a:blip>
-          <a:stretch>
-            <a:fillRect/>
-          </a:stretch>
+          <a:srcRect b="44864" l="43153" r="40663" t="42841"/>
+          <a:stretch/>
         </p:blipFill>
         <p:spPr>
           <a:xfrm>
-            <a:off x="1579763" y="2275875"/>
-            <a:ext cx="1031826" cy="1031826"/>
+            <a:off x="6514275" y="2275875"/>
+            <a:ext cx="1031826" cy="1045176"/>
+          </a:xfrm>
+          <a:prstGeom prst="rect">
+            <a:avLst/>
+          </a:prstGeom>
+          <a:noFill/>
+          <a:ln>
+            <a:noFill/>
+          </a:ln>
+        </p:spPr>
+      </p:pic>
+      <p:pic>
+        <p:nvPicPr>
+          <p:cNvPr id="112" name="Google Shape;112;p22"/>
+          <p:cNvPicPr preferRelativeResize="0"/>
+          <p:nvPr/>
+        </p:nvPicPr>
+        <p:blipFill rotWithShape="1">
+          <a:blip r:embed="rId7">
+            <a:alphaModFix/>
+          </a:blip>
+          <a:srcRect b="53444" l="3895" r="56438" t="26495"/>
+          <a:stretch/>
+        </p:blipFill>
+        <p:spPr>
+          <a:xfrm>
+            <a:off x="4932000" y="2241575"/>
+            <a:ext cx="979193" cy="1100425"/>
           </a:xfrm>
           <a:prstGeom prst="rect">
             <a:avLst/>
@@ -14430,7 +14711,7 @@
   <p:cSld>
     <p:spTree>
       <p:nvGrpSpPr>
-        <p:cNvPr id="115" name="Shape 115"/>
+        <p:cNvPr id="116" name="Shape 116"/>
         <p:cNvGrpSpPr/>
         <p:nvPr/>
       </p:nvGrpSpPr>
@@ -14444,7 +14725,7 @@
       </p:grpSpPr>
       <p:sp>
         <p:nvSpPr>
-          <p:cNvPr id="116" name="Google Shape;116;p23"/>
+          <p:cNvPr id="117" name="Google Shape;117;p23"/>
           <p:cNvSpPr txBox="1"/>
           <p:nvPr>
             <p:ph type="title"/>
@@ -14452,7 +14733,7 @@
         </p:nvSpPr>
         <p:spPr>
           <a:xfrm>
-            <a:off x="228600" y="228600"/>
+            <a:off x="228750" y="903563"/>
             <a:ext cx="8686500" cy="572700"/>
           </a:xfrm>
           <a:prstGeom prst="rect">
@@ -14484,7 +14765,7 @@
       </p:sp>
       <p:sp>
         <p:nvSpPr>
-          <p:cNvPr id="117" name="Google Shape;117;p23"/>
+          <p:cNvPr id="118" name="Google Shape;118;p23"/>
           <p:cNvSpPr txBox="1"/>
           <p:nvPr>
             <p:ph idx="1" type="subTitle"/>
@@ -14492,7 +14773,7 @@
         </p:nvSpPr>
         <p:spPr>
           <a:xfrm>
-            <a:off x="513256" y="1874225"/>
+            <a:off x="513206" y="2912938"/>
             <a:ext cx="3903300" cy="738900"/>
           </a:xfrm>
           <a:prstGeom prst="rect">
@@ -14524,7 +14805,7 @@
       </p:sp>
       <p:sp>
         <p:nvSpPr>
-          <p:cNvPr id="118" name="Google Shape;118;p23"/>
+          <p:cNvPr id="119" name="Google Shape;119;p23"/>
           <p:cNvSpPr txBox="1"/>
           <p:nvPr>
             <p:ph idx="2" type="subTitle"/>
@@ -14532,7 +14813,7 @@
         </p:nvSpPr>
         <p:spPr>
           <a:xfrm>
-            <a:off x="4727444" y="1874225"/>
+            <a:off x="4727394" y="2912938"/>
             <a:ext cx="3903300" cy="738900"/>
           </a:xfrm>
           <a:prstGeom prst="rect">
@@ -14564,7 +14845,7 @@
       </p:sp>
       <p:sp>
         <p:nvSpPr>
-          <p:cNvPr id="119" name="Google Shape;119;p23"/>
+          <p:cNvPr id="120" name="Google Shape;120;p23"/>
           <p:cNvSpPr txBox="1"/>
           <p:nvPr>
             <p:ph idx="5" type="subTitle"/>
@@ -14572,7 +14853,7 @@
         </p:nvSpPr>
         <p:spPr>
           <a:xfrm>
-            <a:off x="513257" y="1519325"/>
+            <a:off x="513207" y="2558038"/>
             <a:ext cx="3903300" cy="431100"/>
           </a:xfrm>
           <a:prstGeom prst="rect">
@@ -14596,7 +14877,7 @@
             </a:pPr>
             <a:r>
               <a:rPr lang="en"/>
-              <a:t>Identificar Requisits</a:t>
+              <a:t>3- Identificar Requisits</a:t>
             </a:r>
             <a:endParaRPr/>
           </a:p>
@@ -14604,7 +14885,7 @@
       </p:sp>
       <p:sp>
         <p:nvSpPr>
-          <p:cNvPr id="120" name="Google Shape;120;p23"/>
+          <p:cNvPr id="121" name="Google Shape;121;p23"/>
           <p:cNvSpPr txBox="1"/>
           <p:nvPr>
             <p:ph idx="6" type="subTitle"/>
@@ -14612,7 +14893,7 @@
         </p:nvSpPr>
         <p:spPr>
           <a:xfrm>
-            <a:off x="513257" y="3057700"/>
+            <a:off x="513282" y="3580838"/>
             <a:ext cx="3903300" cy="431100"/>
           </a:xfrm>
           <a:prstGeom prst="rect">
@@ -14636,7 +14917,7 @@
             </a:pPr>
             <a:r>
               <a:rPr lang="en"/>
-              <a:t>Passar-ho tot al Power Point</a:t>
+              <a:t>5- Passar-ho tot al Power Point</a:t>
             </a:r>
             <a:endParaRPr/>
           </a:p>
@@ -14644,7 +14925,7 @@
       </p:sp>
       <p:sp>
         <p:nvSpPr>
-          <p:cNvPr id="121" name="Google Shape;121;p23"/>
+          <p:cNvPr id="122" name="Google Shape;122;p23"/>
           <p:cNvSpPr txBox="1"/>
           <p:nvPr>
             <p:ph idx="7" type="subTitle"/>
@@ -14652,7 +14933,7 @@
         </p:nvSpPr>
         <p:spPr>
           <a:xfrm>
-            <a:off x="4727408" y="1519325"/>
+            <a:off x="4727358" y="2558038"/>
             <a:ext cx="3903300" cy="431100"/>
           </a:xfrm>
           <a:prstGeom prst="rect">
@@ -14676,7 +14957,7 @@
             </a:pPr>
             <a:r>
               <a:rPr lang="en"/>
-              <a:t>Identificar perfils d’usuari</a:t>
+              <a:t>4- Identificar perfils d’usuari</a:t>
             </a:r>
             <a:endParaRPr/>
           </a:p>
@@ -14684,7 +14965,7 @@
       </p:sp>
       <p:sp>
         <p:nvSpPr>
-          <p:cNvPr id="122" name="Google Shape;122;p23"/>
+          <p:cNvPr id="123" name="Google Shape;123;p23"/>
           <p:cNvSpPr txBox="1"/>
           <p:nvPr>
             <p:ph idx="8" type="subTitle"/>
@@ -14692,7 +14973,7 @@
         </p:nvSpPr>
         <p:spPr>
           <a:xfrm>
-            <a:off x="4727400" y="3057700"/>
+            <a:off x="4727425" y="3580838"/>
             <a:ext cx="3903300" cy="659100"/>
           </a:xfrm>
           <a:prstGeom prst="rect">
@@ -14761,7 +15042,132 @@
             </a:pPr>
             <a:r>
               <a:rPr lang="en"/>
-              <a:t>Fer el fitxer Markdown de cada requeriment</a:t>
+              <a:t>6- Fer el fitxer Markdown de cada requeriment</a:t>
+            </a:r>
+            <a:endParaRPr/>
+          </a:p>
+        </p:txBody>
+      </p:sp>
+      <p:sp>
+        <p:nvSpPr>
+          <p:cNvPr id="124" name="Google Shape;124;p23"/>
+          <p:cNvSpPr txBox="1"/>
+          <p:nvPr>
+            <p:ph idx="6" type="subTitle"/>
+          </p:nvPr>
+        </p:nvSpPr>
+        <p:spPr>
+          <a:xfrm>
+            <a:off x="513357" y="1898925"/>
+            <a:ext cx="3903300" cy="431100"/>
+          </a:xfrm>
+          <a:prstGeom prst="rect">
+            <a:avLst/>
+          </a:prstGeom>
+        </p:spPr>
+        <p:txBody>
+          <a:bodyPr anchorCtr="0" anchor="b" bIns="91425" lIns="91425" spcFirstLastPara="1" rIns="91425" wrap="square" tIns="91425">
+            <a:noAutofit/>
+          </a:bodyPr>
+          <a:lstStyle/>
+          <a:p>
+            <a:pPr indent="0" lvl="0" marL="0" rtl="0" algn="ctr">
+              <a:spcBef>
+                <a:spcPts val="0"/>
+              </a:spcBef>
+              <a:spcAft>
+                <a:spcPts val="0"/>
+              </a:spcAft>
+              <a:buNone/>
+            </a:pPr>
+            <a:r>
+              <a:rPr lang="en"/>
+              <a:t>1- Fer un repositori en GitHub</a:t>
+            </a:r>
+            <a:endParaRPr/>
+          </a:p>
+        </p:txBody>
+      </p:sp>
+      <p:sp>
+        <p:nvSpPr>
+          <p:cNvPr id="125" name="Google Shape;125;p23"/>
+          <p:cNvSpPr txBox="1"/>
+          <p:nvPr>
+            <p:ph idx="8" type="subTitle"/>
+          </p:nvPr>
+        </p:nvSpPr>
+        <p:spPr>
+          <a:xfrm>
+            <a:off x="4727500" y="1898925"/>
+            <a:ext cx="3903300" cy="659100"/>
+          </a:xfrm>
+          <a:prstGeom prst="rect">
+            <a:avLst/>
+          </a:prstGeom>
+        </p:spPr>
+        <p:txBody>
+          <a:bodyPr anchorCtr="0" anchor="b" bIns="91425" lIns="91425" spcFirstLastPara="1" rIns="91425" wrap="square" tIns="91425">
+            <a:noAutofit/>
+          </a:bodyPr>
+          <a:lstStyle/>
+          <a:p>
+            <a:pPr indent="0" lvl="0" marL="0" rtl="0" algn="ctr">
+              <a:spcBef>
+                <a:spcPts val="0"/>
+              </a:spcBef>
+              <a:spcAft>
+                <a:spcPts val="0"/>
+              </a:spcAft>
+              <a:buNone/>
+            </a:pPr>
+            <a:r>
+              <a:t/>
+            </a:r>
+            <a:endParaRPr/>
+          </a:p>
+          <a:p>
+            <a:pPr indent="0" lvl="0" marL="0" rtl="0" algn="ctr">
+              <a:spcBef>
+                <a:spcPts val="0"/>
+              </a:spcBef>
+              <a:spcAft>
+                <a:spcPts val="0"/>
+              </a:spcAft>
+              <a:buNone/>
+            </a:pPr>
+            <a:r>
+              <a:t/>
+            </a:r>
+            <a:endParaRPr/>
+          </a:p>
+          <a:p>
+            <a:pPr indent="0" lvl="0" marL="0" rtl="0" algn="ctr">
+              <a:spcBef>
+                <a:spcPts val="0"/>
+              </a:spcBef>
+              <a:spcAft>
+                <a:spcPts val="0"/>
+              </a:spcAft>
+              <a:buNone/>
+            </a:pPr>
+            <a:r>
+              <a:rPr lang="en"/>
+              <a:t>2- Fer un tauler en Trello</a:t>
+            </a:r>
+            <a:endParaRPr/>
+          </a:p>
+          <a:p>
+            <a:pPr indent="0" lvl="0" marL="0" rtl="0" algn="l">
+              <a:spcBef>
+                <a:spcPts val="0"/>
+              </a:spcBef>
+              <a:spcAft>
+                <a:spcPts val="0"/>
+              </a:spcAft>
+              <a:buNone/>
+            </a:pPr>
+            <a:r>
+              <a:t/>
             </a:r>
             <a:endParaRPr/>
           </a:p>
@@ -14780,7 +15186,7 @@
   <p:cSld>
     <p:spTree>
       <p:nvGrpSpPr>
-        <p:cNvPr id="126" name="Shape 126"/>
+        <p:cNvPr id="129" name="Shape 129"/>
         <p:cNvGrpSpPr/>
         <p:nvPr/>
       </p:nvGrpSpPr>
@@ -14794,7 +15200,7 @@
       </p:grpSpPr>
       <p:sp>
         <p:nvSpPr>
-          <p:cNvPr id="127" name="Google Shape;127;p24"/>
+          <p:cNvPr id="130" name="Google Shape;130;p24"/>
           <p:cNvSpPr/>
           <p:nvPr/>
         </p:nvSpPr>
@@ -14842,7 +15248,7 @@
       </p:sp>
       <p:sp>
         <p:nvSpPr>
-          <p:cNvPr id="128" name="Google Shape;128;p24"/>
+          <p:cNvPr id="131" name="Google Shape;131;p24"/>
           <p:cNvSpPr txBox="1"/>
           <p:nvPr>
             <p:ph type="title"/>
@@ -14882,7 +15288,7 @@
       </p:sp>
       <p:sp>
         <p:nvSpPr>
-          <p:cNvPr id="129" name="Google Shape;129;p24"/>
+          <p:cNvPr id="132" name="Google Shape;132;p24"/>
           <p:cNvSpPr txBox="1"/>
           <p:nvPr>
             <p:ph idx="6" type="subTitle"/>
@@ -14922,7 +15328,7 @@
       </p:sp>
       <p:sp>
         <p:nvSpPr>
-          <p:cNvPr id="130" name="Google Shape;130;p24"/>
+          <p:cNvPr id="133" name="Google Shape;133;p24"/>
           <p:cNvSpPr txBox="1"/>
           <p:nvPr>
             <p:ph idx="1" type="subTitle"/>
@@ -14970,7 +15376,7 @@
       </p:sp>
       <p:sp>
         <p:nvSpPr>
-          <p:cNvPr id="131" name="Google Shape;131;p24"/>
+          <p:cNvPr id="134" name="Google Shape;134;p24"/>
           <p:cNvSpPr/>
           <p:nvPr/>
         </p:nvSpPr>
@@ -15018,7 +15424,7 @@
       </p:sp>
       <p:sp>
         <p:nvSpPr>
-          <p:cNvPr id="132" name="Google Shape;132;p24"/>
+          <p:cNvPr id="135" name="Google Shape;135;p24"/>
           <p:cNvSpPr/>
           <p:nvPr/>
         </p:nvSpPr>
@@ -15066,7 +15472,7 @@
       </p:sp>
       <p:sp>
         <p:nvSpPr>
-          <p:cNvPr id="133" name="Google Shape;133;p24"/>
+          <p:cNvPr id="136" name="Google Shape;136;p24"/>
           <p:cNvSpPr txBox="1"/>
           <p:nvPr>
             <p:ph idx="2" type="subTitle"/>
@@ -15106,7 +15512,7 @@
       </p:sp>
       <p:sp>
         <p:nvSpPr>
-          <p:cNvPr id="134" name="Google Shape;134;p24"/>
+          <p:cNvPr id="137" name="Google Shape;137;p24"/>
           <p:cNvSpPr txBox="1"/>
           <p:nvPr>
             <p:ph idx="7" type="subTitle"/>
@@ -15146,7 +15552,7 @@
       </p:sp>
       <p:sp>
         <p:nvSpPr>
-          <p:cNvPr id="135" name="Google Shape;135;p24"/>
+          <p:cNvPr id="138" name="Google Shape;138;p24"/>
           <p:cNvSpPr txBox="1"/>
           <p:nvPr>
             <p:ph idx="1" type="subTitle"/>
@@ -15186,7 +15592,7 @@
       </p:sp>
       <p:sp>
         <p:nvSpPr>
-          <p:cNvPr id="136" name="Google Shape;136;p24"/>
+          <p:cNvPr id="139" name="Google Shape;139;p24"/>
           <p:cNvSpPr txBox="1"/>
           <p:nvPr>
             <p:ph idx="5" type="subTitle"/>
@@ -15226,7 +15632,7 @@
       </p:sp>
       <p:pic>
         <p:nvPicPr>
-          <p:cNvPr id="137" name="Google Shape;137;p24" title="Recetas de pasta de Karlos Arguiñano _ Web oficial Antena 3.jpg"/>
+          <p:cNvPr id="140" name="Google Shape;140;p24" title="Recetas de pasta de Karlos Arguiñano _ Web oficial Antena 3.jpg"/>
           <p:cNvPicPr preferRelativeResize="0"/>
           <p:nvPr/>
         </p:nvPicPr>
@@ -15255,7 +15661,7 @@
       </p:pic>
       <p:pic>
         <p:nvPicPr>
-          <p:cNvPr id="138" name="Google Shape;138;p24" title="meme drôle.jpg"/>
+          <p:cNvPr id="141" name="Google Shape;141;p24" title="meme drôle.jpg"/>
           <p:cNvPicPr preferRelativeResize="0"/>
           <p:nvPr/>
         </p:nvPicPr>
@@ -15284,7 +15690,7 @@
       </p:pic>
       <p:pic>
         <p:nvPicPr>
-          <p:cNvPr id="139" name="Google Shape;139;p24" title="Pizza Delivery Man stock image_ Image of smiling, italian - 7741877.jpg"/>
+          <p:cNvPr id="142" name="Google Shape;142;p24" title="Pizza Delivery Man stock image_ Image of smiling, italian - 7741877.jpg"/>
           <p:cNvPicPr preferRelativeResize="0"/>
           <p:nvPr/>
         </p:nvPicPr>
@@ -15322,7 +15728,7 @@
   <p:cSld>
     <p:spTree>
       <p:nvGrpSpPr>
-        <p:cNvPr id="143" name="Shape 143"/>
+        <p:cNvPr id="146" name="Shape 146"/>
         <p:cNvGrpSpPr/>
         <p:nvPr/>
       </p:nvGrpSpPr>
@@ -15336,7 +15742,7 @@
       </p:grpSpPr>
       <p:sp>
         <p:nvSpPr>
-          <p:cNvPr id="144" name="Google Shape;144;p25"/>
+          <p:cNvPr id="147" name="Google Shape;147;p25"/>
           <p:cNvSpPr txBox="1"/>
           <p:nvPr>
             <p:ph type="title"/>
@@ -15376,7 +15782,7 @@
       </p:sp>
       <p:sp>
         <p:nvSpPr>
-          <p:cNvPr id="145" name="Google Shape;145;p25"/>
+          <p:cNvPr id="148" name="Google Shape;148;p25"/>
           <p:cNvSpPr txBox="1"/>
           <p:nvPr/>
         </p:nvSpPr>
@@ -15535,12 +15941,20 @@
               <a:buNone/>
             </a:pPr>
             <a:r>
+              <a:rPr b="1" lang="en" u="sng">
+                <a:solidFill>
+                  <a:schemeClr val="dk1"/>
+                </a:solidFill>
+              </a:rPr>
+              <a:t>RNF 3</a:t>
+            </a:r>
+            <a:r>
               <a:rPr b="1" lang="en">
                 <a:solidFill>
                   <a:schemeClr val="dk1"/>
                 </a:solidFill>
               </a:rPr>
-              <a:t>RNF 3: </a:t>
+              <a:t>: </a:t>
             </a:r>
             <a:r>
               <a:rPr lang="en">
@@ -15548,7 +15962,23 @@
                   <a:schemeClr val="dk1"/>
                 </a:solidFill>
               </a:rPr>
-              <a:t>Els clients podran registrar-se amb Gmail o amb Outlook (RNF de Decisió de disseny). </a:t>
+              <a:t>Els clients podran registrar-se amb Gmail o amb Outlook (RNF de </a:t>
+            </a:r>
+            <a:r>
+              <a:rPr lang="en" u="sng">
+                <a:solidFill>
+                  <a:schemeClr val="dk1"/>
+                </a:solidFill>
+              </a:rPr>
+              <a:t>Decisió de disseny</a:t>
+            </a:r>
+            <a:r>
+              <a:rPr lang="en">
+                <a:solidFill>
+                  <a:schemeClr val="dk1"/>
+                </a:solidFill>
+              </a:rPr>
+              <a:t>). </a:t>
             </a:r>
             <a:endParaRPr>
               <a:solidFill>
@@ -15639,12 +16069,20 @@
               <a:buNone/>
             </a:pPr>
             <a:r>
+              <a:rPr b="1" lang="en" u="sng">
+                <a:solidFill>
+                  <a:schemeClr val="dk1"/>
+                </a:solidFill>
+              </a:rPr>
+              <a:t>RNF 6</a:t>
+            </a:r>
+            <a:r>
               <a:rPr b="1" lang="en">
                 <a:solidFill>
                   <a:schemeClr val="dk1"/>
                 </a:solidFill>
               </a:rPr>
-              <a:t>RNF 6: </a:t>
+              <a:t>: </a:t>
             </a:r>
             <a:r>
               <a:rPr lang="en">
@@ -15652,7 +16090,23 @@
                   <a:schemeClr val="dk1"/>
                 </a:solidFill>
               </a:rPr>
-              <a:t>El nom d’usuari ha de tenir més de 5 caràcters (RNF de Decisió de disseny). </a:t>
+              <a:t>El nom d’usuari ha de tenir més de 5 caràcters (RNF de </a:t>
+            </a:r>
+            <a:r>
+              <a:rPr lang="en" u="sng">
+                <a:solidFill>
+                  <a:schemeClr val="dk1"/>
+                </a:solidFill>
+              </a:rPr>
+              <a:t>Decisió de disseny</a:t>
+            </a:r>
+            <a:r>
+              <a:rPr lang="en">
+                <a:solidFill>
+                  <a:schemeClr val="dk1"/>
+                </a:solidFill>
+              </a:rPr>
+              <a:t>). </a:t>
             </a:r>
             <a:endParaRPr>
               <a:solidFill>
@@ -15703,12 +16157,20 @@
               <a:buNone/>
             </a:pPr>
             <a:r>
+              <a:rPr b="1" lang="en" u="sng">
+                <a:solidFill>
+                  <a:schemeClr val="dk1"/>
+                </a:solidFill>
+              </a:rPr>
+              <a:t>RNF 8</a:t>
+            </a:r>
+            <a:r>
               <a:rPr b="1" lang="en">
                 <a:solidFill>
                   <a:schemeClr val="dk1"/>
                 </a:solidFill>
               </a:rPr>
-              <a:t>RNF 8: </a:t>
+              <a:t>: </a:t>
             </a:r>
             <a:r>
               <a:rPr lang="en">
@@ -15716,7 +16178,23 @@
                   <a:schemeClr val="dk1"/>
                 </a:solidFill>
               </a:rPr>
-              <a:t>La contrasenya ha de tenir més de 8 caràcters, tenir 2 majúscules i més de 2 caràcters especials. (RNF de Decisió de disseny). </a:t>
+              <a:t>La contrasenya ha de tenir més de 8 caràcters, tenir 2 majúscules i més de 2 caràcters especials. (RNF de </a:t>
+            </a:r>
+            <a:r>
+              <a:rPr lang="en" u="sng">
+                <a:solidFill>
+                  <a:schemeClr val="dk1"/>
+                </a:solidFill>
+              </a:rPr>
+              <a:t>Decisió de disseny</a:t>
+            </a:r>
+            <a:r>
+              <a:rPr lang="en">
+                <a:solidFill>
+                  <a:schemeClr val="dk1"/>
+                </a:solidFill>
+              </a:rPr>
+              <a:t>). </a:t>
             </a:r>
             <a:endParaRPr>
               <a:solidFill>
@@ -15839,12 +16317,20 @@
               <a:buNone/>
             </a:pPr>
             <a:r>
+              <a:rPr b="1" lang="en" u="sng">
+                <a:solidFill>
+                  <a:schemeClr val="dk1"/>
+                </a:solidFill>
+              </a:rPr>
+              <a:t>RNF 12</a:t>
+            </a:r>
+            <a:r>
               <a:rPr b="1" lang="en">
                 <a:solidFill>
                   <a:schemeClr val="dk1"/>
                 </a:solidFill>
               </a:rPr>
-              <a:t>RNF 12: </a:t>
+              <a:t>: </a:t>
             </a:r>
             <a:r>
               <a:rPr lang="en">
@@ -15852,7 +16338,23 @@
                   <a:schemeClr val="dk1"/>
                 </a:solidFill>
               </a:rPr>
-              <a:t>Els rols que s'han assumit es poden modificar en qualsevol moment. (RNF de Decisió de disseny).</a:t>
+              <a:t>Els rols que s'han assumit es poden modificar en qualsevol moment. (RNF de </a:t>
+            </a:r>
+            <a:r>
+              <a:rPr lang="en" u="sng">
+                <a:solidFill>
+                  <a:schemeClr val="dk1"/>
+                </a:solidFill>
+              </a:rPr>
+              <a:t>Decisió de disseny</a:t>
+            </a:r>
+            <a:r>
+              <a:rPr lang="en">
+                <a:solidFill>
+                  <a:schemeClr val="dk1"/>
+                </a:solidFill>
+              </a:rPr>
+              <a:t>).</a:t>
             </a:r>
             <a:endParaRPr>
               <a:solidFill>
@@ -15875,7 +16377,7 @@
   <p:cSld>
     <p:spTree>
       <p:nvGrpSpPr>
-        <p:cNvPr id="149" name="Shape 149"/>
+        <p:cNvPr id="152" name="Shape 152"/>
         <p:cNvGrpSpPr/>
         <p:nvPr/>
       </p:nvGrpSpPr>
@@ -15889,7 +16391,7 @@
       </p:grpSpPr>
       <p:sp>
         <p:nvSpPr>
-          <p:cNvPr id="150" name="Google Shape;150;p26"/>
+          <p:cNvPr id="153" name="Google Shape;153;p26"/>
           <p:cNvSpPr txBox="1"/>
           <p:nvPr>
             <p:ph type="title"/>
@@ -15929,7 +16431,7 @@
       </p:sp>
       <p:sp>
         <p:nvSpPr>
-          <p:cNvPr id="151" name="Google Shape;151;p26"/>
+          <p:cNvPr id="154" name="Google Shape;154;p26"/>
           <p:cNvSpPr txBox="1"/>
           <p:nvPr/>
         </p:nvSpPr>
@@ -16069,12 +16571,20 @@
               <a:buNone/>
             </a:pPr>
             <a:r>
+              <a:rPr b="1" lang="en" sz="1300" u="sng">
+                <a:solidFill>
+                  <a:schemeClr val="dk1"/>
+                </a:solidFill>
+              </a:rPr>
+              <a:t>RNF 15</a:t>
+            </a:r>
+            <a:r>
               <a:rPr b="1" lang="en" sz="1300">
                 <a:solidFill>
                   <a:schemeClr val="dk1"/>
                 </a:solidFill>
               </a:rPr>
-              <a:t>RNF 15: </a:t>
+              <a:t>: </a:t>
             </a:r>
             <a:r>
               <a:rPr lang="en" sz="1300">
@@ -16082,7 +16592,23 @@
                   <a:schemeClr val="dk1"/>
                 </a:solidFill>
               </a:rPr>
-              <a:t>Es mostraran primer els plats i menús que compleixen amb les restriccions alimentaries indicades al perfil. (RNF de Decisió de disseny). </a:t>
+              <a:t>Es mostraran primer els plats i menús que compleixen amb les restriccions alimentaries indicades al perfil. (RNF de </a:t>
+            </a:r>
+            <a:r>
+              <a:rPr lang="en" sz="1300" u="sng">
+                <a:solidFill>
+                  <a:schemeClr val="dk1"/>
+                </a:solidFill>
+              </a:rPr>
+              <a:t>Decisió de disseny</a:t>
+            </a:r>
+            <a:r>
+              <a:rPr lang="en" sz="1300">
+                <a:solidFill>
+                  <a:schemeClr val="dk1"/>
+                </a:solidFill>
+              </a:rPr>
+              <a:t>). </a:t>
             </a:r>
             <a:endParaRPr sz="1300">
               <a:solidFill>
@@ -16101,12 +16627,20 @@
               <a:buNone/>
             </a:pPr>
             <a:r>
+              <a:rPr b="1" lang="en" sz="1300" u="sng">
+                <a:solidFill>
+                  <a:schemeClr val="dk1"/>
+                </a:solidFill>
+              </a:rPr>
+              <a:t>RNF 16</a:t>
+            </a:r>
+            <a:r>
               <a:rPr b="1" lang="en" sz="1300">
                 <a:solidFill>
                   <a:schemeClr val="dk1"/>
                 </a:solidFill>
               </a:rPr>
-              <a:t>RNF 16: </a:t>
+              <a:t>: </a:t>
             </a:r>
             <a:r>
               <a:rPr lang="en" sz="1300">
@@ -16114,7 +16648,23 @@
                   <a:schemeClr val="dk1"/>
                 </a:solidFill>
               </a:rPr>
-              <a:t>També es visualitza el temps estimat d'entrega (RNF de Interfície externa). </a:t>
+              <a:t>També es visualitza el temps estimat d'entrega (RNF de </a:t>
+            </a:r>
+            <a:r>
+              <a:rPr lang="en" sz="1300" u="sng">
+                <a:solidFill>
+                  <a:schemeClr val="dk1"/>
+                </a:solidFill>
+              </a:rPr>
+              <a:t>Interfície externa</a:t>
+            </a:r>
+            <a:r>
+              <a:rPr lang="en" sz="1300">
+                <a:solidFill>
+                  <a:schemeClr val="dk1"/>
+                </a:solidFill>
+              </a:rPr>
+              <a:t>). </a:t>
             </a:r>
             <a:endParaRPr sz="1300">
               <a:solidFill>
@@ -16165,12 +16715,20 @@
               <a:buNone/>
             </a:pPr>
             <a:r>
+              <a:rPr b="1" lang="en" sz="1300" u="sng">
+                <a:solidFill>
+                  <a:schemeClr val="dk1"/>
+                </a:solidFill>
+              </a:rPr>
+              <a:t>RNF 18</a:t>
+            </a:r>
+            <a:r>
               <a:rPr b="1" lang="en" sz="1300">
                 <a:solidFill>
                   <a:schemeClr val="dk1"/>
                 </a:solidFill>
               </a:rPr>
-              <a:t>RNF 18: </a:t>
+              <a:t>: </a:t>
             </a:r>
             <a:r>
               <a:rPr lang="en" sz="1300">
@@ -16178,7 +16736,23 @@
                   <a:schemeClr val="dk1"/>
                 </a:solidFill>
               </a:rPr>
-              <a:t>Les dos llistes seran ordenades segons la distància física entre client i cuiner (RNF de Decisió de disseny).</a:t>
+              <a:t>Les dos llistes seran ordenades segons la distància física entre client i cuiner (RNF de </a:t>
+            </a:r>
+            <a:r>
+              <a:rPr lang="en" sz="1300" u="sng">
+                <a:solidFill>
+                  <a:schemeClr val="dk1"/>
+                </a:solidFill>
+              </a:rPr>
+              <a:t>Decisió de disseny</a:t>
+            </a:r>
+            <a:r>
+              <a:rPr lang="en" sz="1300">
+                <a:solidFill>
+                  <a:schemeClr val="dk1"/>
+                </a:solidFill>
+              </a:rPr>
+              <a:t>).</a:t>
             </a:r>
             <a:r>
               <a:rPr b="1" lang="en" sz="1300">
@@ -16237,12 +16811,20 @@
               <a:buNone/>
             </a:pPr>
             <a:r>
+              <a:rPr b="1" lang="en" sz="1300" u="sng">
+                <a:solidFill>
+                  <a:schemeClr val="dk1"/>
+                </a:solidFill>
+              </a:rPr>
+              <a:t>RNF 20</a:t>
+            </a:r>
+            <a:r>
               <a:rPr b="1" lang="en" sz="1300">
                 <a:solidFill>
                   <a:schemeClr val="dk1"/>
                 </a:solidFill>
               </a:rPr>
-              <a:t>RNF 20: </a:t>
+              <a:t>: </a:t>
             </a:r>
             <a:r>
               <a:rPr lang="en" sz="1300">
@@ -16250,7 +16832,23 @@
                   <a:schemeClr val="dk1"/>
                 </a:solidFill>
               </a:rPr>
-              <a:t>Els cuiners poden aparèixer en el llistat com a no disponibles, indicant l'hora en què poden acceptar comandes. (RNF de Decisió de disseny). </a:t>
+              <a:t>Els cuiners poden aparèixer en el llistat com a no disponibles, indicant l'hora en què poden acceptar comandes. (RNF de </a:t>
+            </a:r>
+            <a:r>
+              <a:rPr lang="en" sz="1300" u="sng">
+                <a:solidFill>
+                  <a:schemeClr val="dk1"/>
+                </a:solidFill>
+              </a:rPr>
+              <a:t>Decisió de disseny</a:t>
+            </a:r>
+            <a:r>
+              <a:rPr lang="en" sz="1300">
+                <a:solidFill>
+                  <a:schemeClr val="dk1"/>
+                </a:solidFill>
+              </a:rPr>
+              <a:t>). </a:t>
             </a:r>
             <a:endParaRPr sz="1300">
               <a:solidFill>
@@ -16301,12 +16899,20 @@
               <a:buNone/>
             </a:pPr>
             <a:r>
+              <a:rPr b="1" lang="en" sz="1300" u="sng">
+                <a:solidFill>
+                  <a:schemeClr val="dk1"/>
+                </a:solidFill>
+              </a:rPr>
+              <a:t>RNF 22</a:t>
+            </a:r>
+            <a:r>
               <a:rPr b="1" lang="en" sz="1300">
                 <a:solidFill>
                   <a:schemeClr val="dk1"/>
                 </a:solidFill>
               </a:rPr>
-              <a:t>RNF 22: </a:t>
+              <a:t>: </a:t>
             </a:r>
             <a:r>
               <a:rPr lang="en" sz="1300">
@@ -16314,7 +16920,23 @@
                   <a:schemeClr val="dk1"/>
                 </a:solidFill>
               </a:rPr>
-              <a:t>Un mateix client no podrà tenir més de tres comandes actives alhora. (RNF de Rendiment estàtic). </a:t>
+              <a:t>Un mateix client no podrà tenir més de tres comandes actives alhora. (RNF de </a:t>
+            </a:r>
+            <a:r>
+              <a:rPr lang="en" sz="1300" u="sng">
+                <a:solidFill>
+                  <a:schemeClr val="dk1"/>
+                </a:solidFill>
+              </a:rPr>
+              <a:t>Rendiment estàtic</a:t>
+            </a:r>
+            <a:r>
+              <a:rPr lang="en" sz="1300">
+                <a:solidFill>
+                  <a:schemeClr val="dk1"/>
+                </a:solidFill>
+              </a:rPr>
+              <a:t>). </a:t>
             </a:r>
             <a:endParaRPr sz="1300">
               <a:solidFill>
@@ -16388,7 +17010,7 @@
   <p:cSld>
     <p:spTree>
       <p:nvGrpSpPr>
-        <p:cNvPr id="155" name="Shape 155"/>
+        <p:cNvPr id="158" name="Shape 158"/>
         <p:cNvGrpSpPr/>
         <p:nvPr/>
       </p:nvGrpSpPr>
@@ -16402,7 +17024,7 @@
       </p:grpSpPr>
       <p:sp>
         <p:nvSpPr>
-          <p:cNvPr id="156" name="Google Shape;156;p27"/>
+          <p:cNvPr id="159" name="Google Shape;159;p27"/>
           <p:cNvSpPr txBox="1"/>
           <p:nvPr>
             <p:ph type="title"/>
@@ -16442,7 +17064,7 @@
       </p:sp>
       <p:sp>
         <p:nvSpPr>
-          <p:cNvPr id="157" name="Google Shape;157;p27"/>
+          <p:cNvPr id="160" name="Google Shape;160;p27"/>
           <p:cNvSpPr txBox="1"/>
           <p:nvPr/>
         </p:nvSpPr>
@@ -16681,12 +17303,20 @@
               <a:buNone/>
             </a:pPr>
             <a:r>
+              <a:rPr b="1" lang="en" u="sng">
+                <a:solidFill>
+                  <a:schemeClr val="dk1"/>
+                </a:solidFill>
+              </a:rPr>
+              <a:t>RNF 28</a:t>
+            </a:r>
+            <a:r>
               <a:rPr b="1" lang="en">
                 <a:solidFill>
                   <a:schemeClr val="dk1"/>
                 </a:solidFill>
               </a:rPr>
-              <a:t>RNF 28: </a:t>
+              <a:t>: </a:t>
             </a:r>
             <a:r>
               <a:rPr lang="en">
@@ -16694,7 +17324,23 @@
                   <a:schemeClr val="dk1"/>
                 </a:solidFill>
               </a:rPr>
-              <a:t>La posició del repartidor es mostra en un mapa utilitzant la interfície de Google Maps. (RNF d’Interfícies Externes). </a:t>
+              <a:t>La posició del repartidor es mostra en un mapa utilitzant la interfície de Google Maps. (RNF </a:t>
+            </a:r>
+            <a:r>
+              <a:rPr lang="en" u="sng">
+                <a:solidFill>
+                  <a:schemeClr val="dk1"/>
+                </a:solidFill>
+              </a:rPr>
+              <a:t>d’Interfícies Externes</a:t>
+            </a:r>
+            <a:r>
+              <a:rPr lang="en">
+                <a:solidFill>
+                  <a:schemeClr val="dk1"/>
+                </a:solidFill>
+              </a:rPr>
+              <a:t>). </a:t>
             </a:r>
             <a:endParaRPr>
               <a:solidFill>
@@ -16736,7 +17382,7 @@
   <p:cSld>
     <p:spTree>
       <p:nvGrpSpPr>
-        <p:cNvPr id="161" name="Shape 161"/>
+        <p:cNvPr id="164" name="Shape 164"/>
         <p:cNvGrpSpPr/>
         <p:nvPr/>
       </p:nvGrpSpPr>
@@ -16750,7 +17396,7 @@
       </p:grpSpPr>
       <p:sp>
         <p:nvSpPr>
-          <p:cNvPr id="162" name="Google Shape;162;p28"/>
+          <p:cNvPr id="165" name="Google Shape;165;p28"/>
           <p:cNvSpPr txBox="1"/>
           <p:nvPr>
             <p:ph type="title"/>
@@ -16790,7 +17436,7 @@
       </p:sp>
       <p:sp>
         <p:nvSpPr>
-          <p:cNvPr id="163" name="Google Shape;163;p28"/>
+          <p:cNvPr id="166" name="Google Shape;166;p28"/>
           <p:cNvSpPr txBox="1"/>
           <p:nvPr/>
         </p:nvSpPr>
@@ -16917,12 +17563,20 @@
               <a:buNone/>
             </a:pPr>
             <a:r>
+              <a:rPr b="1" lang="en" u="sng">
+                <a:solidFill>
+                  <a:schemeClr val="dk1"/>
+                </a:solidFill>
+              </a:rPr>
+              <a:t>RNF 30</a:t>
+            </a:r>
+            <a:r>
               <a:rPr b="1" lang="en">
                 <a:solidFill>
                   <a:schemeClr val="dk1"/>
                 </a:solidFill>
               </a:rPr>
-              <a:t>RNF 30: </a:t>
+              <a:t>: </a:t>
             </a:r>
             <a:r>
               <a:rPr lang="en">
@@ -16930,7 +17584,23 @@
                   <a:schemeClr val="dk1"/>
                 </a:solidFill>
               </a:rPr>
-              <a:t>El sistema s'ha de connectar amb la plataforma de pagament corresponent per autenticar les dades i confirmar la transacció. (RNF d’Interfícies Externes). </a:t>
+              <a:t>El sistema s'ha de connectar amb la plataforma de pagament corresponent per autenticar les dades i confirmar la transacció. (RNF </a:t>
+            </a:r>
+            <a:r>
+              <a:rPr lang="en" u="sng">
+                <a:solidFill>
+                  <a:schemeClr val="dk1"/>
+                </a:solidFill>
+              </a:rPr>
+              <a:t>d’Interfícies Externes</a:t>
+            </a:r>
+            <a:r>
+              <a:rPr lang="en">
+                <a:solidFill>
+                  <a:schemeClr val="dk1"/>
+                </a:solidFill>
+              </a:rPr>
+              <a:t>). </a:t>
             </a:r>
             <a:endParaRPr>
               <a:solidFill>
@@ -16981,12 +17651,20 @@
               <a:buNone/>
             </a:pPr>
             <a:r>
+              <a:rPr b="1" lang="en" u="sng">
+                <a:solidFill>
+                  <a:schemeClr val="dk1"/>
+                </a:solidFill>
+              </a:rPr>
+              <a:t>RNF 32</a:t>
+            </a:r>
+            <a:r>
               <a:rPr b="1" lang="en">
                 <a:solidFill>
                   <a:schemeClr val="dk1"/>
                 </a:solidFill>
               </a:rPr>
-              <a:t>RNF 32: </a:t>
+              <a:t>: </a:t>
             </a:r>
             <a:r>
               <a:rPr lang="en">
@@ -16994,7 +17672,23 @@
                   <a:schemeClr val="dk1"/>
                 </a:solidFill>
               </a:rPr>
-              <a:t>El cuiner i el repartidor han de tenir un compte bancari associat al seu perfil d'usuari. (RNF de Restricció de Disseny, seguretat). </a:t>
+              <a:t>El cuiner i el repartidor han de tenir un compte bancari associat al seu perfil d'usuari. (RNF de </a:t>
+            </a:r>
+            <a:r>
+              <a:rPr lang="en" u="sng">
+                <a:solidFill>
+                  <a:schemeClr val="dk1"/>
+                </a:solidFill>
+              </a:rPr>
+              <a:t>Restricció de Disseny, seguretat</a:t>
+            </a:r>
+            <a:r>
+              <a:rPr lang="en">
+                <a:solidFill>
+                  <a:schemeClr val="dk1"/>
+                </a:solidFill>
+              </a:rPr>
+              <a:t>). </a:t>
             </a:r>
             <a:endParaRPr>
               <a:solidFill>
@@ -17036,7 +17730,7 @@
   <p:cSld>
     <p:spTree>
       <p:nvGrpSpPr>
-        <p:cNvPr id="167" name="Shape 167"/>
+        <p:cNvPr id="170" name="Shape 170"/>
         <p:cNvGrpSpPr/>
         <p:nvPr/>
       </p:nvGrpSpPr>
@@ -17050,7 +17744,7 @@
       </p:grpSpPr>
       <p:sp>
         <p:nvSpPr>
-          <p:cNvPr id="168" name="Google Shape;168;p29"/>
+          <p:cNvPr id="171" name="Google Shape;171;p29"/>
           <p:cNvSpPr txBox="1"/>
           <p:nvPr>
             <p:ph type="title"/>
@@ -17090,7 +17784,7 @@
       </p:sp>
       <p:sp>
         <p:nvSpPr>
-          <p:cNvPr id="169" name="Google Shape;169;p29"/>
+          <p:cNvPr id="172" name="Google Shape;172;p29"/>
           <p:cNvSpPr txBox="1"/>
           <p:nvPr/>
         </p:nvSpPr>
@@ -17267,12 +17961,20 @@
               <a:buNone/>
             </a:pPr>
             <a:r>
+              <a:rPr b="1" lang="en" u="sng">
+                <a:solidFill>
+                  <a:schemeClr val="dk1"/>
+                </a:solidFill>
+              </a:rPr>
+              <a:t>RNF 35</a:t>
+            </a:r>
+            <a:r>
               <a:rPr b="1" lang="en">
                 <a:solidFill>
                   <a:schemeClr val="dk1"/>
                 </a:solidFill>
               </a:rPr>
-              <a:t>RNF 35: </a:t>
+              <a:t>: </a:t>
             </a:r>
             <a:r>
               <a:rPr lang="en">
@@ -17280,7 +17982,23 @@
                   <a:schemeClr val="dk1"/>
                 </a:solidFill>
               </a:rPr>
-              <a:t>Els cuiners recomanats s’ordenen segons la seva valoració (a major valoració, més amunt apareixen). (RNF de Decisió de Disseny). </a:t>
+              <a:t>Els cuiners recomanats s’ordenen segons la seva valoració (a major valoració, més amunt apareixen). (RNF de </a:t>
+            </a:r>
+            <a:r>
+              <a:rPr lang="en" u="sng">
+                <a:solidFill>
+                  <a:schemeClr val="dk1"/>
+                </a:solidFill>
+              </a:rPr>
+              <a:t>Decisió de Disseny</a:t>
+            </a:r>
+            <a:r>
+              <a:rPr lang="en">
+                <a:solidFill>
+                  <a:schemeClr val="dk1"/>
+                </a:solidFill>
+              </a:rPr>
+              <a:t>). </a:t>
             </a:r>
             <a:endParaRPr>
               <a:solidFill>

</xml_diff>

<commit_message>
Actualització Doc Especificacions i Sprint Review 1
Versions "definitives", en principi.
</commit_message>
<xml_diff>
--- a/Documents/Sprint_Reviews/Sprint_Review01.pptx
+++ b/Documents/Sprint_Reviews/Sprint_Review01.pptx
@@ -2,42 +2,42 @@
 <file path=ppt/presentation.xml><?xml version="1.0" encoding="utf-8"?>
 <p:presentation xmlns:a="http://schemas.openxmlformats.org/drawingml/2006/main" xmlns:r="http://schemas.openxmlformats.org/officeDocument/2006/relationships" xmlns:mc="http://schemas.openxmlformats.org/markup-compatibility/2006" xmlns:mv="urn:schemas-microsoft-com:mac:vml" xmlns:p="http://schemas.openxmlformats.org/presentationml/2006/main" xmlns:c="http://schemas.openxmlformats.org/drawingml/2006/chart" xmlns:dgm="http://schemas.openxmlformats.org/drawingml/2006/diagram" xmlns:o="urn:schemas-microsoft-com:office:office" xmlns:v="urn:schemas-microsoft-com:vml" xmlns:pvml="urn:schemas-microsoft-com:office:powerpoint" xmlns:com="http://schemas.openxmlformats.org/drawingml/2006/compatibility" xmlns:p14="http://schemas.microsoft.com/office/powerpoint/2010/main" xmlns:p15="http://schemas.microsoft.com/office/powerpoint/2012/main" xmlns:ahyp="http://schemas.microsoft.com/office/drawing/2018/hyperlinkcolor" autoCompressPictures="0" embedTrueTypeFonts="1" strictFirstAndLastChars="0" saveSubsetFonts="1">
   <p:sldMasterIdLst>
-    <p:sldMasterId id="2147483667" r:id="rId4"/>
+    <p:sldMasterId id="2147483667" r:id="rId3"/>
   </p:sldMasterIdLst>
   <p:notesMasterIdLst>
-    <p:notesMasterId r:id="rId5"/>
+    <p:notesMasterId r:id="rId4"/>
   </p:notesMasterIdLst>
   <p:sldIdLst>
-    <p:sldId id="256" r:id="rId6"/>
-    <p:sldId id="257" r:id="rId7"/>
-    <p:sldId id="258" r:id="rId8"/>
-    <p:sldId id="259" r:id="rId9"/>
-    <p:sldId id="260" r:id="rId10"/>
-    <p:sldId id="261" r:id="rId11"/>
-    <p:sldId id="262" r:id="rId12"/>
-    <p:sldId id="263" r:id="rId13"/>
-    <p:sldId id="264" r:id="rId14"/>
-    <p:sldId id="265" r:id="rId15"/>
-    <p:sldId id="266" r:id="rId16"/>
-    <p:sldId id="267" r:id="rId17"/>
+    <p:sldId id="256" r:id="rId5"/>
+    <p:sldId id="257" r:id="rId6"/>
+    <p:sldId id="258" r:id="rId7"/>
+    <p:sldId id="259" r:id="rId8"/>
+    <p:sldId id="260" r:id="rId9"/>
+    <p:sldId id="261" r:id="rId10"/>
+    <p:sldId id="262" r:id="rId11"/>
+    <p:sldId id="263" r:id="rId12"/>
+    <p:sldId id="264" r:id="rId13"/>
+    <p:sldId id="265" r:id="rId14"/>
+    <p:sldId id="266" r:id="rId15"/>
+    <p:sldId id="267" r:id="rId16"/>
   </p:sldIdLst>
   <p:sldSz cy="5143500" cx="9144000"/>
   <p:notesSz cx="6858000" cy="9144000"/>
   <p:embeddedFontLst>
     <p:embeddedFont>
       <p:font typeface="Hind"/>
-      <p:regular r:id="rId18"/>
-      <p:bold r:id="rId19"/>
+      <p:regular r:id="rId17"/>
+      <p:bold r:id="rId18"/>
     </p:embeddedFont>
     <p:embeddedFont>
       <p:font typeface="Space Grotesk Medium"/>
-      <p:regular r:id="rId20"/>
-      <p:bold r:id="rId21"/>
+      <p:regular r:id="rId19"/>
+      <p:bold r:id="rId20"/>
     </p:embeddedFont>
     <p:embeddedFont>
       <p:font typeface="Space Grotesk"/>
-      <p:regular r:id="rId22"/>
-      <p:bold r:id="rId23"/>
+      <p:regular r:id="rId21"/>
+      <p:bold r:id="rId22"/>
     </p:embeddedFont>
   </p:embeddedFontLst>
   <p:defaultTextStyle>
@@ -270,26 +270,6 @@
     </a:lvl9pPr>
   </p:defaultTextStyle>
 </p:presentation>
-</file>
-
-<file path=ppt/commentAuthors.xml><?xml version="1.0" encoding="utf-8"?>
-<p:cmAuthorLst xmlns:a="http://schemas.openxmlformats.org/drawingml/2006/main" xmlns:r="http://schemas.openxmlformats.org/officeDocument/2006/relationships" xmlns:mc="http://schemas.openxmlformats.org/markup-compatibility/2006" xmlns:mv="urn:schemas-microsoft-com:mac:vml" xmlns:p="http://schemas.openxmlformats.org/presentationml/2006/main" xmlns:c="http://schemas.openxmlformats.org/drawingml/2006/chart" xmlns:dgm="http://schemas.openxmlformats.org/drawingml/2006/diagram" xmlns:o="urn:schemas-microsoft-com:office:office" xmlns:v="urn:schemas-microsoft-com:vml" xmlns:pvml="urn:schemas-microsoft-com:office:powerpoint" xmlns:com="http://schemas.openxmlformats.org/drawingml/2006/compatibility" xmlns:p14="http://schemas.microsoft.com/office/powerpoint/2010/main" xmlns:p15="http://schemas.microsoft.com/office/powerpoint/2012/main" xmlns:ahyp="http://schemas.microsoft.com/office/drawing/2018/hyperlinkcolor">
-  <p:cmAuthor clrIdx="0" id="0" initials="" lastIdx="1" name="Marina Martín"/>
-</p:cmAuthorLst>
-</file>
-
-<file path=ppt/comments/comment1.xml><?xml version="1.0" encoding="utf-8"?>
-<p:cmLst xmlns:a="http://schemas.openxmlformats.org/drawingml/2006/main" xmlns:r="http://schemas.openxmlformats.org/officeDocument/2006/relationships" xmlns:mc="http://schemas.openxmlformats.org/markup-compatibility/2006" xmlns:mv="urn:schemas-microsoft-com:mac:vml" xmlns:p="http://schemas.openxmlformats.org/presentationml/2006/main" xmlns:c="http://schemas.openxmlformats.org/drawingml/2006/chart" xmlns:dgm="http://schemas.openxmlformats.org/drawingml/2006/diagram" xmlns:o="urn:schemas-microsoft-com:office:office" xmlns:v="urn:schemas-microsoft-com:vml" xmlns:pvml="urn:schemas-microsoft-com:office:powerpoint" xmlns:com="http://schemas.openxmlformats.org/drawingml/2006/compatibility" xmlns:p14="http://schemas.microsoft.com/office/powerpoint/2010/main" xmlns:p15="http://schemas.microsoft.com/office/powerpoint/2012/main" xmlns:ahyp="http://schemas.microsoft.com/office/drawing/2018/hyperlinkcolor">
-  <p:cm authorId="0" idx="1" dt="2026-03-15T11:01:39.703">
-    <p:pos x="6000" y="0"/>
-    <p:text>Tasques: 
-- Identificar requisits
-- Identificar perfils d'usuari
-- Escriure-ho al doc d'especificacions
-- Escriure-ho al powepoint
-- Fer els .md de cada requisit</p:text>
-  </p:cm>
-</p:cmLst>
 </file>
 
 <file path=ppt/notesMasters/notesMaster1.xml><?xml version="1.0" encoding="utf-8"?>
@@ -822,7 +802,7 @@
   <p:cSld>
     <p:spTree>
       <p:nvGrpSpPr>
-        <p:cNvPr id="173" name="Shape 173"/>
+        <p:cNvPr id="167" name="Shape 167"/>
         <p:cNvGrpSpPr/>
         <p:nvPr/>
       </p:nvGrpSpPr>
@@ -836,7 +816,7 @@
       </p:grpSpPr>
       <p:sp>
         <p:nvSpPr>
-          <p:cNvPr id="174" name="Google Shape;174;g396060f51c5_0_26:notes"/>
+          <p:cNvPr id="168" name="Google Shape;168;g396060f51c5_0_26:notes"/>
           <p:cNvSpPr/>
           <p:nvPr>
             <p:ph idx="2" type="sldImg"/>
@@ -871,7 +851,7 @@
       </p:sp>
       <p:sp>
         <p:nvSpPr>
-          <p:cNvPr id="175" name="Google Shape;175;g396060f51c5_0_26:notes"/>
+          <p:cNvPr id="169" name="Google Shape;169;g396060f51c5_0_26:notes"/>
           <p:cNvSpPr txBox="1"/>
           <p:nvPr>
             <p:ph idx="1" type="body"/>
@@ -921,7 +901,7 @@
   <p:cSld>
     <p:spTree>
       <p:nvGrpSpPr>
-        <p:cNvPr id="179" name="Shape 179"/>
+        <p:cNvPr id="173" name="Shape 173"/>
         <p:cNvGrpSpPr/>
         <p:nvPr/>
       </p:nvGrpSpPr>
@@ -935,7 +915,7 @@
       </p:grpSpPr>
       <p:sp>
         <p:nvSpPr>
-          <p:cNvPr id="180" name="Google Shape;180;g396060f51c5_0_31:notes"/>
+          <p:cNvPr id="174" name="Google Shape;174;g396060f51c5_0_31:notes"/>
           <p:cNvSpPr/>
           <p:nvPr>
             <p:ph idx="2" type="sldImg"/>
@@ -970,7 +950,7 @@
       </p:sp>
       <p:sp>
         <p:nvSpPr>
-          <p:cNvPr id="181" name="Google Shape;181;g396060f51c5_0_31:notes"/>
+          <p:cNvPr id="175" name="Google Shape;175;g396060f51c5_0_31:notes"/>
           <p:cNvSpPr txBox="1"/>
           <p:nvPr>
             <p:ph idx="1" type="body"/>
@@ -1020,7 +1000,7 @@
   <p:cSld>
     <p:spTree>
       <p:nvGrpSpPr>
-        <p:cNvPr id="185" name="Shape 185"/>
+        <p:cNvPr id="179" name="Shape 179"/>
         <p:cNvGrpSpPr/>
         <p:nvPr/>
       </p:nvGrpSpPr>
@@ -1034,7 +1014,7 @@
       </p:grpSpPr>
       <p:sp>
         <p:nvSpPr>
-          <p:cNvPr id="186" name="Google Shape;186;g3cf70ef3b9e_0_30:notes"/>
+          <p:cNvPr id="180" name="Google Shape;180;g3cf70ef3b9e_0_30:notes"/>
           <p:cNvSpPr/>
           <p:nvPr>
             <p:ph idx="2" type="sldImg"/>
@@ -1069,7 +1049,7 @@
       </p:sp>
       <p:sp>
         <p:nvSpPr>
-          <p:cNvPr id="187" name="Google Shape;187;g3cf70ef3b9e_0_30:notes"/>
+          <p:cNvPr id="181" name="Google Shape;181;g3cf70ef3b9e_0_30:notes"/>
           <p:cNvSpPr txBox="1"/>
           <p:nvPr>
             <p:ph idx="1" type="body"/>
@@ -1232,7 +1212,7 @@
       </p:grpSpPr>
       <p:sp>
         <p:nvSpPr>
-          <p:cNvPr id="114" name="Google Shape;114;g3cf70ef3b9e_0_10:notes"/>
+          <p:cNvPr id="114" name="Google Shape;114;g3d02d10b557_0_19:notes"/>
           <p:cNvSpPr/>
           <p:nvPr>
             <p:ph idx="2" type="sldImg"/>
@@ -1267,7 +1247,7 @@
       </p:sp>
       <p:sp>
         <p:nvSpPr>
-          <p:cNvPr id="115" name="Google Shape;115;g3cf70ef3b9e_0_10:notes"/>
+          <p:cNvPr id="115" name="Google Shape;115;g3d02d10b557_0_19:notes"/>
           <p:cNvSpPr txBox="1"/>
           <p:nvPr>
             <p:ph idx="1" type="body"/>
@@ -1317,7 +1297,7 @@
   <p:cSld>
     <p:spTree>
       <p:nvGrpSpPr>
-        <p:cNvPr id="126" name="Shape 126"/>
+        <p:cNvPr id="120" name="Shape 120"/>
         <p:cNvGrpSpPr/>
         <p:nvPr/>
       </p:nvGrpSpPr>
@@ -1331,7 +1311,7 @@
       </p:grpSpPr>
       <p:sp>
         <p:nvSpPr>
-          <p:cNvPr id="127" name="Google Shape;127;g3d02b607959_0_2:notes"/>
+          <p:cNvPr id="121" name="Google Shape;121;g3d02b607959_0_2:notes"/>
           <p:cNvSpPr/>
           <p:nvPr>
             <p:ph idx="2" type="sldImg"/>
@@ -1366,7 +1346,7 @@
       </p:sp>
       <p:sp>
         <p:nvSpPr>
-          <p:cNvPr id="128" name="Google Shape;128;g3d02b607959_0_2:notes"/>
+          <p:cNvPr id="122" name="Google Shape;122;g3d02b607959_0_2:notes"/>
           <p:cNvSpPr txBox="1"/>
           <p:nvPr>
             <p:ph idx="1" type="body"/>
@@ -1416,7 +1396,7 @@
   <p:cSld>
     <p:spTree>
       <p:nvGrpSpPr>
-        <p:cNvPr id="143" name="Shape 143"/>
+        <p:cNvPr id="137" name="Shape 137"/>
         <p:cNvGrpSpPr/>
         <p:nvPr/>
       </p:nvGrpSpPr>
@@ -1430,7 +1410,7 @@
       </p:grpSpPr>
       <p:sp>
         <p:nvSpPr>
-          <p:cNvPr id="144" name="Google Shape;144;g3cf70ef3b9e_0_26:notes"/>
+          <p:cNvPr id="138" name="Google Shape;138;g3cf70ef3b9e_0_26:notes"/>
           <p:cNvSpPr/>
           <p:nvPr>
             <p:ph idx="2" type="sldImg"/>
@@ -1465,7 +1445,7 @@
       </p:sp>
       <p:sp>
         <p:nvSpPr>
-          <p:cNvPr id="145" name="Google Shape;145;g3cf70ef3b9e_0_26:notes"/>
+          <p:cNvPr id="139" name="Google Shape;139;g3cf70ef3b9e_0_26:notes"/>
           <p:cNvSpPr txBox="1"/>
           <p:nvPr>
             <p:ph idx="1" type="body"/>
@@ -1515,7 +1495,7 @@
   <p:cSld>
     <p:spTree>
       <p:nvGrpSpPr>
-        <p:cNvPr id="149" name="Shape 149"/>
+        <p:cNvPr id="143" name="Shape 143"/>
         <p:cNvGrpSpPr/>
         <p:nvPr/>
       </p:nvGrpSpPr>
@@ -1529,7 +1509,7 @@
       </p:grpSpPr>
       <p:sp>
         <p:nvSpPr>
-          <p:cNvPr id="150" name="Google Shape;150;g396060f51c5_0_1:notes"/>
+          <p:cNvPr id="144" name="Google Shape;144;g396060f51c5_0_1:notes"/>
           <p:cNvSpPr/>
           <p:nvPr>
             <p:ph idx="2" type="sldImg"/>
@@ -1564,7 +1544,7 @@
       </p:sp>
       <p:sp>
         <p:nvSpPr>
-          <p:cNvPr id="151" name="Google Shape;151;g396060f51c5_0_1:notes"/>
+          <p:cNvPr id="145" name="Google Shape;145;g396060f51c5_0_1:notes"/>
           <p:cNvSpPr txBox="1"/>
           <p:nvPr>
             <p:ph idx="1" type="body"/>
@@ -1614,7 +1594,7 @@
   <p:cSld>
     <p:spTree>
       <p:nvGrpSpPr>
-        <p:cNvPr id="155" name="Shape 155"/>
+        <p:cNvPr id="149" name="Shape 149"/>
         <p:cNvGrpSpPr/>
         <p:nvPr/>
       </p:nvGrpSpPr>
@@ -1628,7 +1608,7 @@
       </p:grpSpPr>
       <p:sp>
         <p:nvSpPr>
-          <p:cNvPr id="156" name="Google Shape;156;g396060f51c5_0_6:notes"/>
+          <p:cNvPr id="150" name="Google Shape;150;g396060f51c5_0_6:notes"/>
           <p:cNvSpPr/>
           <p:nvPr>
             <p:ph idx="2" type="sldImg"/>
@@ -1663,7 +1643,7 @@
       </p:sp>
       <p:sp>
         <p:nvSpPr>
-          <p:cNvPr id="157" name="Google Shape;157;g396060f51c5_0_6:notes"/>
+          <p:cNvPr id="151" name="Google Shape;151;g396060f51c5_0_6:notes"/>
           <p:cNvSpPr txBox="1"/>
           <p:nvPr>
             <p:ph idx="1" type="body"/>
@@ -1713,7 +1693,7 @@
   <p:cSld>
     <p:spTree>
       <p:nvGrpSpPr>
-        <p:cNvPr id="161" name="Shape 161"/>
+        <p:cNvPr id="155" name="Shape 155"/>
         <p:cNvGrpSpPr/>
         <p:nvPr/>
       </p:nvGrpSpPr>
@@ -1727,7 +1707,7 @@
       </p:grpSpPr>
       <p:sp>
         <p:nvSpPr>
-          <p:cNvPr id="162" name="Google Shape;162;g396060f51c5_0_11:notes"/>
+          <p:cNvPr id="156" name="Google Shape;156;g396060f51c5_0_11:notes"/>
           <p:cNvSpPr/>
           <p:nvPr>
             <p:ph idx="2" type="sldImg"/>
@@ -1762,7 +1742,7 @@
       </p:sp>
       <p:sp>
         <p:nvSpPr>
-          <p:cNvPr id="163" name="Google Shape;163;g396060f51c5_0_11:notes"/>
+          <p:cNvPr id="157" name="Google Shape;157;g396060f51c5_0_11:notes"/>
           <p:cNvSpPr txBox="1"/>
           <p:nvPr>
             <p:ph idx="1" type="body"/>
@@ -1812,7 +1792,7 @@
   <p:cSld>
     <p:spTree>
       <p:nvGrpSpPr>
-        <p:cNvPr id="167" name="Shape 167"/>
+        <p:cNvPr id="161" name="Shape 161"/>
         <p:cNvGrpSpPr/>
         <p:nvPr/>
       </p:nvGrpSpPr>
@@ -1826,7 +1806,7 @@
       </p:grpSpPr>
       <p:sp>
         <p:nvSpPr>
-          <p:cNvPr id="168" name="Google Shape;168;g396060f51c5_0_16:notes"/>
+          <p:cNvPr id="162" name="Google Shape;162;g396060f51c5_0_16:notes"/>
           <p:cNvSpPr/>
           <p:nvPr>
             <p:ph idx="2" type="sldImg"/>
@@ -1861,7 +1841,7 @@
       </p:sp>
       <p:sp>
         <p:nvSpPr>
-          <p:cNvPr id="169" name="Google Shape;169;g396060f51c5_0_16:notes"/>
+          <p:cNvPr id="163" name="Google Shape;163;g396060f51c5_0_16:notes"/>
           <p:cNvSpPr txBox="1"/>
           <p:nvPr>
             <p:ph idx="1" type="body"/>
@@ -13095,7 +13075,7 @@
   <p:cSld>
     <p:spTree>
       <p:nvGrpSpPr>
-        <p:cNvPr id="176" name="Shape 176"/>
+        <p:cNvPr id="170" name="Shape 170"/>
         <p:cNvGrpSpPr/>
         <p:nvPr/>
       </p:nvGrpSpPr>
@@ -13109,7 +13089,7 @@
       </p:grpSpPr>
       <p:sp>
         <p:nvSpPr>
-          <p:cNvPr id="177" name="Google Shape;177;p30"/>
+          <p:cNvPr id="171" name="Google Shape;171;p30"/>
           <p:cNvSpPr txBox="1"/>
           <p:nvPr>
             <p:ph type="title"/>
@@ -13149,7 +13129,7 @@
       </p:sp>
       <p:sp>
         <p:nvSpPr>
-          <p:cNvPr id="178" name="Google Shape;178;p30"/>
+          <p:cNvPr id="172" name="Google Shape;172;p30"/>
           <p:cNvSpPr txBox="1"/>
           <p:nvPr/>
         </p:nvSpPr>
@@ -13456,7 +13436,7 @@
   <p:cSld>
     <p:spTree>
       <p:nvGrpSpPr>
-        <p:cNvPr id="182" name="Shape 182"/>
+        <p:cNvPr id="176" name="Shape 176"/>
         <p:cNvGrpSpPr/>
         <p:nvPr/>
       </p:nvGrpSpPr>
@@ -13470,7 +13450,7 @@
       </p:grpSpPr>
       <p:sp>
         <p:nvSpPr>
-          <p:cNvPr id="183" name="Google Shape;183;p31"/>
+          <p:cNvPr id="177" name="Google Shape;177;p31"/>
           <p:cNvSpPr txBox="1"/>
           <p:nvPr>
             <p:ph type="title"/>
@@ -13510,7 +13490,7 @@
       </p:sp>
       <p:sp>
         <p:nvSpPr>
-          <p:cNvPr id="184" name="Google Shape;184;p31"/>
+          <p:cNvPr id="178" name="Google Shape;178;p31"/>
           <p:cNvSpPr txBox="1"/>
           <p:nvPr/>
         </p:nvSpPr>
@@ -14208,7 +14188,7 @@
   <p:cSld>
     <p:spTree>
       <p:nvGrpSpPr>
-        <p:cNvPr id="188" name="Shape 188"/>
+        <p:cNvPr id="182" name="Shape 182"/>
         <p:cNvGrpSpPr/>
         <p:nvPr/>
       </p:nvGrpSpPr>
@@ -14222,7 +14202,7 @@
       </p:grpSpPr>
       <p:sp>
         <p:nvSpPr>
-          <p:cNvPr id="189" name="Google Shape;189;p32"/>
+          <p:cNvPr id="183" name="Google Shape;183;p32"/>
           <p:cNvSpPr txBox="1"/>
           <p:nvPr>
             <p:ph type="title"/>
@@ -14262,7 +14242,7 @@
       </p:sp>
       <p:pic>
         <p:nvPicPr>
-          <p:cNvPr id="190" name="Google Shape;190;p32"/>
+          <p:cNvPr id="184" name="Google Shape;184;p32"/>
           <p:cNvPicPr preferRelativeResize="0"/>
           <p:nvPr/>
         </p:nvPicPr>
@@ -14290,7 +14270,7 @@
       </p:pic>
       <p:pic>
         <p:nvPicPr>
-          <p:cNvPr id="191" name="Google Shape;191;p32"/>
+          <p:cNvPr id="185" name="Google Shape;185;p32"/>
           <p:cNvPicPr preferRelativeResize="0"/>
           <p:nvPr/>
         </p:nvPicPr>
@@ -14733,8 +14713,8 @@
         </p:nvSpPr>
         <p:spPr>
           <a:xfrm>
-            <a:off x="228750" y="903563"/>
-            <a:ext cx="8686500" cy="572700"/>
+            <a:off x="0" y="228600"/>
+            <a:ext cx="5251500" cy="572700"/>
           </a:xfrm>
           <a:prstGeom prst="rect">
             <a:avLst/>
@@ -14757,24 +14737,51 @@
             </a:pPr>
             <a:r>
               <a:rPr lang="en"/>
-              <a:t>Tasques fetes al sprint</a:t>
+              <a:t>Tasques fetes a l’sprint</a:t>
             </a:r>
             <a:endParaRPr/>
           </a:p>
         </p:txBody>
       </p:sp>
+      <p:pic>
+        <p:nvPicPr>
+          <p:cNvPr id="118" name="Google Shape;118;p23"/>
+          <p:cNvPicPr preferRelativeResize="0"/>
+          <p:nvPr/>
+        </p:nvPicPr>
+        <p:blipFill rotWithShape="1">
+          <a:blip r:embed="rId3">
+            <a:alphaModFix/>
+          </a:blip>
+          <a:srcRect b="0" l="0" r="0" t="6638"/>
+          <a:stretch/>
+        </p:blipFill>
+        <p:spPr>
+          <a:xfrm>
+            <a:off x="5251554" y="0"/>
+            <a:ext cx="3892446" cy="5143500"/>
+          </a:xfrm>
+          <a:prstGeom prst="rect">
+            <a:avLst/>
+          </a:prstGeom>
+          <a:noFill/>
+          <a:ln>
+            <a:noFill/>
+          </a:ln>
+        </p:spPr>
+      </p:pic>
       <p:sp>
         <p:nvSpPr>
-          <p:cNvPr id="118" name="Google Shape;118;p23"/>
+          <p:cNvPr id="119" name="Google Shape;119;p23"/>
           <p:cNvSpPr txBox="1"/>
           <p:nvPr>
-            <p:ph idx="1" type="subTitle"/>
+            <p:ph idx="6" type="subTitle"/>
           </p:nvPr>
         </p:nvSpPr>
         <p:spPr>
           <a:xfrm>
-            <a:off x="513206" y="2912938"/>
-            <a:ext cx="3903300" cy="738900"/>
+            <a:off x="785400" y="1405125"/>
+            <a:ext cx="3680700" cy="2910000"/>
           </a:xfrm>
           <a:prstGeom prst="rect">
             <a:avLst/>
@@ -14796,209 +14803,10 @@
               <a:buNone/>
             </a:pPr>
             <a:r>
-              <a:rPr lang="en"/>
-              <a:t>(i escriure’ls al Document d’Especificacions)</a:t>
-            </a:r>
-            <a:endParaRPr/>
-          </a:p>
-        </p:txBody>
-      </p:sp>
-      <p:sp>
-        <p:nvSpPr>
-          <p:cNvPr id="119" name="Google Shape;119;p23"/>
-          <p:cNvSpPr txBox="1"/>
-          <p:nvPr>
-            <p:ph idx="2" type="subTitle"/>
-          </p:nvPr>
-        </p:nvSpPr>
-        <p:spPr>
-          <a:xfrm>
-            <a:off x="4727394" y="2912938"/>
-            <a:ext cx="3903300" cy="738900"/>
-          </a:xfrm>
-          <a:prstGeom prst="rect">
-            <a:avLst/>
-          </a:prstGeom>
-        </p:spPr>
-        <p:txBody>
-          <a:bodyPr anchorCtr="0" anchor="t" bIns="91425" lIns="91425" spcFirstLastPara="1" rIns="91425" wrap="square" tIns="91425">
-            <a:noAutofit/>
-          </a:bodyPr>
-          <a:lstStyle/>
-          <a:p>
-            <a:pPr indent="0" lvl="0" marL="0" rtl="0" algn="ctr">
-              <a:spcBef>
-                <a:spcPts val="0"/>
-              </a:spcBef>
-              <a:spcAft>
-                <a:spcPts val="0"/>
-              </a:spcAft>
-              <a:buNone/>
-            </a:pPr>
-            <a:r>
-              <a:rPr lang="en"/>
-              <a:t>(i escriure’ls al Document d’Especificacions)</a:t>
-            </a:r>
-            <a:endParaRPr/>
-          </a:p>
-        </p:txBody>
-      </p:sp>
-      <p:sp>
-        <p:nvSpPr>
-          <p:cNvPr id="120" name="Google Shape;120;p23"/>
-          <p:cNvSpPr txBox="1"/>
-          <p:nvPr>
-            <p:ph idx="5" type="subTitle"/>
-          </p:nvPr>
-        </p:nvSpPr>
-        <p:spPr>
-          <a:xfrm>
-            <a:off x="513207" y="2558038"/>
-            <a:ext cx="3903300" cy="431100"/>
-          </a:xfrm>
-          <a:prstGeom prst="rect">
-            <a:avLst/>
-          </a:prstGeom>
-        </p:spPr>
-        <p:txBody>
-          <a:bodyPr anchorCtr="0" anchor="b" bIns="91425" lIns="91425" spcFirstLastPara="1" rIns="91425" wrap="square" tIns="91425">
-            <a:noAutofit/>
-          </a:bodyPr>
-          <a:lstStyle/>
-          <a:p>
-            <a:pPr indent="0" lvl="0" marL="0" rtl="0" algn="ctr">
-              <a:spcBef>
-                <a:spcPts val="0"/>
-              </a:spcBef>
-              <a:spcAft>
-                <a:spcPts val="0"/>
-              </a:spcAft>
-              <a:buNone/>
-            </a:pPr>
-            <a:r>
-              <a:rPr lang="en"/>
-              <a:t>3- Identificar Requisits</a:t>
-            </a:r>
-            <a:endParaRPr/>
-          </a:p>
-        </p:txBody>
-      </p:sp>
-      <p:sp>
-        <p:nvSpPr>
-          <p:cNvPr id="121" name="Google Shape;121;p23"/>
-          <p:cNvSpPr txBox="1"/>
-          <p:nvPr>
-            <p:ph idx="6" type="subTitle"/>
-          </p:nvPr>
-        </p:nvSpPr>
-        <p:spPr>
-          <a:xfrm>
-            <a:off x="513282" y="3580838"/>
-            <a:ext cx="3903300" cy="431100"/>
-          </a:xfrm>
-          <a:prstGeom prst="rect">
-            <a:avLst/>
-          </a:prstGeom>
-        </p:spPr>
-        <p:txBody>
-          <a:bodyPr anchorCtr="0" anchor="b" bIns="91425" lIns="91425" spcFirstLastPara="1" rIns="91425" wrap="square" tIns="91425">
-            <a:noAutofit/>
-          </a:bodyPr>
-          <a:lstStyle/>
-          <a:p>
-            <a:pPr indent="0" lvl="0" marL="0" rtl="0" algn="ctr">
-              <a:spcBef>
-                <a:spcPts val="0"/>
-              </a:spcBef>
-              <a:spcAft>
-                <a:spcPts val="0"/>
-              </a:spcAft>
-              <a:buNone/>
-            </a:pPr>
-            <a:r>
-              <a:rPr lang="en"/>
-              <a:t>5- Passar-ho tot al Power Point</a:t>
-            </a:r>
-            <a:endParaRPr/>
-          </a:p>
-        </p:txBody>
-      </p:sp>
-      <p:sp>
-        <p:nvSpPr>
-          <p:cNvPr id="122" name="Google Shape;122;p23"/>
-          <p:cNvSpPr txBox="1"/>
-          <p:nvPr>
-            <p:ph idx="7" type="subTitle"/>
-          </p:nvPr>
-        </p:nvSpPr>
-        <p:spPr>
-          <a:xfrm>
-            <a:off x="4727358" y="2558038"/>
-            <a:ext cx="3903300" cy="431100"/>
-          </a:xfrm>
-          <a:prstGeom prst="rect">
-            <a:avLst/>
-          </a:prstGeom>
-        </p:spPr>
-        <p:txBody>
-          <a:bodyPr anchorCtr="0" anchor="b" bIns="91425" lIns="91425" spcFirstLastPara="1" rIns="91425" wrap="square" tIns="91425">
-            <a:noAutofit/>
-          </a:bodyPr>
-          <a:lstStyle/>
-          <a:p>
-            <a:pPr indent="0" lvl="0" marL="0" rtl="0" algn="ctr">
-              <a:spcBef>
-                <a:spcPts val="0"/>
-              </a:spcBef>
-              <a:spcAft>
-                <a:spcPts val="0"/>
-              </a:spcAft>
-              <a:buNone/>
-            </a:pPr>
-            <a:r>
-              <a:rPr lang="en"/>
-              <a:t>4- Identificar perfils d’usuari</a:t>
-            </a:r>
-            <a:endParaRPr/>
-          </a:p>
-        </p:txBody>
-      </p:sp>
-      <p:sp>
-        <p:nvSpPr>
-          <p:cNvPr id="123" name="Google Shape;123;p23"/>
-          <p:cNvSpPr txBox="1"/>
-          <p:nvPr>
-            <p:ph idx="8" type="subTitle"/>
-          </p:nvPr>
-        </p:nvSpPr>
-        <p:spPr>
-          <a:xfrm>
-            <a:off x="4727425" y="3580838"/>
-            <a:ext cx="3903300" cy="659100"/>
-          </a:xfrm>
-          <a:prstGeom prst="rect">
-            <a:avLst/>
-          </a:prstGeom>
-        </p:spPr>
-        <p:txBody>
-          <a:bodyPr anchorCtr="0" anchor="b" bIns="91425" lIns="91425" spcFirstLastPara="1" rIns="91425" wrap="square" tIns="91425">
-            <a:noAutofit/>
-          </a:bodyPr>
-          <a:lstStyle/>
-          <a:p>
-            <a:pPr indent="0" lvl="0" marL="0" rtl="0" algn="ctr">
-              <a:spcBef>
-                <a:spcPts val="0"/>
-              </a:spcBef>
-              <a:spcAft>
-                <a:spcPts val="0"/>
-              </a:spcAft>
-              <a:buNone/>
-            </a:pPr>
-            <a:r>
-              <a:t/>
-            </a:r>
-            <a:endParaRPr/>
+              <a:rPr lang="en" sz="1300"/>
+              <a:t>1- Fer un repositori en GitHub</a:t>
+            </a:r>
+            <a:endParaRPr sz="1300"/>
           </a:p>
           <a:p>
             <a:pPr indent="0" lvl="0" marL="0" rtl="0" algn="ctr">
@@ -15013,7 +14821,7 @@
             <a:r>
               <a:t/>
             </a:r>
-            <a:endParaRPr/>
+            <a:endParaRPr sz="1300"/>
           </a:p>
           <a:p>
             <a:pPr indent="0" lvl="0" marL="0" rtl="0" algn="ctr">
@@ -15026,9 +14834,14 @@
               <a:buNone/>
             </a:pPr>
             <a:r>
-              <a:t/>
-            </a:r>
-            <a:endParaRPr/>
+              <a:rPr lang="en" sz="1300"/>
+              <a:t>2- </a:t>
+            </a:r>
+            <a:r>
+              <a:rPr lang="en" sz="1300"/>
+              <a:t>Fer un tauler en Trello</a:t>
+            </a:r>
+            <a:endParaRPr sz="1300"/>
           </a:p>
           <a:p>
             <a:pPr indent="0" lvl="0" marL="0" rtl="0" algn="ctr">
@@ -15041,89 +14854,9 @@
               <a:buNone/>
             </a:pPr>
             <a:r>
-              <a:rPr lang="en"/>
-              <a:t>6- Fer el fitxer Markdown de cada requeriment</a:t>
-            </a:r>
-            <a:endParaRPr/>
-          </a:p>
-        </p:txBody>
-      </p:sp>
-      <p:sp>
-        <p:nvSpPr>
-          <p:cNvPr id="124" name="Google Shape;124;p23"/>
-          <p:cNvSpPr txBox="1"/>
-          <p:nvPr>
-            <p:ph idx="6" type="subTitle"/>
-          </p:nvPr>
-        </p:nvSpPr>
-        <p:spPr>
-          <a:xfrm>
-            <a:off x="513357" y="1898925"/>
-            <a:ext cx="3903300" cy="431100"/>
-          </a:xfrm>
-          <a:prstGeom prst="rect">
-            <a:avLst/>
-          </a:prstGeom>
-        </p:spPr>
-        <p:txBody>
-          <a:bodyPr anchorCtr="0" anchor="b" bIns="91425" lIns="91425" spcFirstLastPara="1" rIns="91425" wrap="square" tIns="91425">
-            <a:noAutofit/>
-          </a:bodyPr>
-          <a:lstStyle/>
-          <a:p>
-            <a:pPr indent="0" lvl="0" marL="0" rtl="0" algn="ctr">
-              <a:spcBef>
-                <a:spcPts val="0"/>
-              </a:spcBef>
-              <a:spcAft>
-                <a:spcPts val="0"/>
-              </a:spcAft>
-              <a:buNone/>
-            </a:pPr>
-            <a:r>
-              <a:rPr lang="en"/>
-              <a:t>1- Fer un repositori en GitHub</a:t>
-            </a:r>
-            <a:endParaRPr/>
-          </a:p>
-        </p:txBody>
-      </p:sp>
-      <p:sp>
-        <p:nvSpPr>
-          <p:cNvPr id="125" name="Google Shape;125;p23"/>
-          <p:cNvSpPr txBox="1"/>
-          <p:nvPr>
-            <p:ph idx="8" type="subTitle"/>
-          </p:nvPr>
-        </p:nvSpPr>
-        <p:spPr>
-          <a:xfrm>
-            <a:off x="4727500" y="1898925"/>
-            <a:ext cx="3903300" cy="659100"/>
-          </a:xfrm>
-          <a:prstGeom prst="rect">
-            <a:avLst/>
-          </a:prstGeom>
-        </p:spPr>
-        <p:txBody>
-          <a:bodyPr anchorCtr="0" anchor="b" bIns="91425" lIns="91425" spcFirstLastPara="1" rIns="91425" wrap="square" tIns="91425">
-            <a:noAutofit/>
-          </a:bodyPr>
-          <a:lstStyle/>
-          <a:p>
-            <a:pPr indent="0" lvl="0" marL="0" rtl="0" algn="ctr">
-              <a:spcBef>
-                <a:spcPts val="0"/>
-              </a:spcBef>
-              <a:spcAft>
-                <a:spcPts val="0"/>
-              </a:spcAft>
-              <a:buNone/>
-            </a:pPr>
-            <a:r>
               <a:t/>
             </a:r>
-            <a:endParaRPr/>
+            <a:endParaRPr sz="1300"/>
           </a:p>
           <a:p>
             <a:pPr indent="0" lvl="0" marL="0" rtl="0" algn="ctr">
@@ -15136,9 +14869,14 @@
               <a:buNone/>
             </a:pPr>
             <a:r>
-              <a:t/>
-            </a:r>
-            <a:endParaRPr/>
+              <a:rPr lang="en" sz="1300"/>
+              <a:t>3- </a:t>
+            </a:r>
+            <a:r>
+              <a:rPr lang="en" sz="1300"/>
+              <a:t>Identificar Requisits</a:t>
+            </a:r>
+            <a:endParaRPr sz="1300"/>
           </a:p>
           <a:p>
             <a:pPr indent="0" lvl="0" marL="0" rtl="0" algn="ctr">
@@ -15151,13 +14889,23 @@
               <a:buNone/>
             </a:pPr>
             <a:r>
-              <a:rPr lang="en"/>
-              <a:t>2- Fer un tauler en Trello</a:t>
-            </a:r>
-            <a:endParaRPr/>
+              <a:rPr b="0" lang="en" sz="900">
+                <a:latin typeface="Hind"/>
+                <a:ea typeface="Hind"/>
+                <a:cs typeface="Hind"/>
+                <a:sym typeface="Hind"/>
+              </a:rPr>
+              <a:t>(i escriure’ls al Document d’Especificacions)</a:t>
+            </a:r>
+            <a:endParaRPr b="0" sz="900">
+              <a:latin typeface="Hind"/>
+              <a:ea typeface="Hind"/>
+              <a:cs typeface="Hind"/>
+              <a:sym typeface="Hind"/>
+            </a:endParaRPr>
           </a:p>
           <a:p>
-            <a:pPr indent="0" lvl="0" marL="0" rtl="0" algn="l">
+            <a:pPr indent="0" lvl="0" marL="0" rtl="0" algn="ctr">
               <a:spcBef>
                 <a:spcPts val="0"/>
               </a:spcBef>
@@ -15169,7 +14917,133 @@
             <a:r>
               <a:t/>
             </a:r>
-            <a:endParaRPr/>
+            <a:endParaRPr sz="1300"/>
+          </a:p>
+          <a:p>
+            <a:pPr indent="0" lvl="0" marL="0" rtl="0" algn="ctr">
+              <a:spcBef>
+                <a:spcPts val="0"/>
+              </a:spcBef>
+              <a:spcAft>
+                <a:spcPts val="0"/>
+              </a:spcAft>
+              <a:buNone/>
+            </a:pPr>
+            <a:r>
+              <a:rPr lang="en" sz="1300"/>
+              <a:t>4- </a:t>
+            </a:r>
+            <a:r>
+              <a:rPr lang="en" sz="1300"/>
+              <a:t>Identificar perfils d’usuari</a:t>
+            </a:r>
+            <a:endParaRPr sz="1300"/>
+          </a:p>
+          <a:p>
+            <a:pPr indent="0" lvl="0" marL="0" rtl="0" algn="ctr">
+              <a:spcBef>
+                <a:spcPts val="0"/>
+              </a:spcBef>
+              <a:spcAft>
+                <a:spcPts val="0"/>
+              </a:spcAft>
+              <a:buNone/>
+            </a:pPr>
+            <a:r>
+              <a:rPr b="0" lang="en" sz="900">
+                <a:latin typeface="Hind"/>
+                <a:ea typeface="Hind"/>
+                <a:cs typeface="Hind"/>
+                <a:sym typeface="Hind"/>
+              </a:rPr>
+              <a:t>(i escriure’ls al Document d’Especificacions)</a:t>
+            </a:r>
+            <a:endParaRPr sz="1300"/>
+          </a:p>
+          <a:p>
+            <a:pPr indent="0" lvl="0" marL="0" rtl="0" algn="ctr">
+              <a:spcBef>
+                <a:spcPts val="0"/>
+              </a:spcBef>
+              <a:spcAft>
+                <a:spcPts val="0"/>
+              </a:spcAft>
+              <a:buNone/>
+            </a:pPr>
+            <a:r>
+              <a:t/>
+            </a:r>
+            <a:endParaRPr sz="1300"/>
+          </a:p>
+          <a:p>
+            <a:pPr indent="0" lvl="0" marL="0" rtl="0" algn="ctr">
+              <a:spcBef>
+                <a:spcPts val="0"/>
+              </a:spcBef>
+              <a:spcAft>
+                <a:spcPts val="0"/>
+              </a:spcAft>
+              <a:buNone/>
+            </a:pPr>
+            <a:r>
+              <a:rPr lang="en" sz="1300"/>
+              <a:t>5- </a:t>
+            </a:r>
+            <a:r>
+              <a:rPr lang="en" sz="1300"/>
+              <a:t>Passar-ho tot al Power Point</a:t>
+            </a:r>
+            <a:endParaRPr sz="1300"/>
+          </a:p>
+          <a:p>
+            <a:pPr indent="0" lvl="0" marL="0" rtl="0" algn="ctr">
+              <a:spcBef>
+                <a:spcPts val="0"/>
+              </a:spcBef>
+              <a:spcAft>
+                <a:spcPts val="0"/>
+              </a:spcAft>
+              <a:buNone/>
+            </a:pPr>
+            <a:r>
+              <a:t/>
+            </a:r>
+            <a:endParaRPr sz="1300"/>
+          </a:p>
+          <a:p>
+            <a:pPr indent="0" lvl="0" marL="0" rtl="0" algn="ctr">
+              <a:spcBef>
+                <a:spcPts val="0"/>
+              </a:spcBef>
+              <a:spcAft>
+                <a:spcPts val="0"/>
+              </a:spcAft>
+              <a:buNone/>
+            </a:pPr>
+            <a:r>
+              <a:rPr lang="en" sz="1300"/>
+              <a:t>6- </a:t>
+            </a:r>
+            <a:r>
+              <a:rPr lang="en" sz="1300"/>
+              <a:t>Fer el fitxer Markdown de cada requeriment</a:t>
+            </a:r>
+            <a:endParaRPr sz="1300"/>
+          </a:p>
+          <a:p>
+            <a:pPr indent="0" lvl="0" marL="0" rtl="0" algn="ctr">
+              <a:spcBef>
+                <a:spcPts val="0"/>
+              </a:spcBef>
+              <a:spcAft>
+                <a:spcPts val="0"/>
+              </a:spcAft>
+              <a:buNone/>
+            </a:pPr>
+            <a:r>
+              <a:t/>
+            </a:r>
+            <a:endParaRPr sz="1300"/>
           </a:p>
         </p:txBody>
       </p:sp>
@@ -15186,7 +15060,7 @@
   <p:cSld>
     <p:spTree>
       <p:nvGrpSpPr>
-        <p:cNvPr id="129" name="Shape 129"/>
+        <p:cNvPr id="123" name="Shape 123"/>
         <p:cNvGrpSpPr/>
         <p:nvPr/>
       </p:nvGrpSpPr>
@@ -15200,13 +15074,13 @@
       </p:grpSpPr>
       <p:sp>
         <p:nvSpPr>
-          <p:cNvPr id="130" name="Google Shape;130;p24"/>
+          <p:cNvPr id="124" name="Google Shape;124;p24"/>
           <p:cNvSpPr/>
           <p:nvPr/>
         </p:nvSpPr>
         <p:spPr>
           <a:xfrm>
-            <a:off x="1561338" y="983825"/>
+            <a:off x="3188325" y="2980175"/>
             <a:ext cx="2943300" cy="2013600"/>
           </a:xfrm>
           <a:prstGeom prst="rect">
@@ -15248,7 +15122,7 @@
       </p:sp>
       <p:sp>
         <p:nvSpPr>
-          <p:cNvPr id="131" name="Google Shape;131;p24"/>
+          <p:cNvPr id="125" name="Google Shape;125;p24"/>
           <p:cNvSpPr txBox="1"/>
           <p:nvPr>
             <p:ph type="title"/>
@@ -15288,7 +15162,7 @@
       </p:sp>
       <p:sp>
         <p:nvSpPr>
-          <p:cNvPr id="132" name="Google Shape;132;p24"/>
+          <p:cNvPr id="126" name="Google Shape;126;p24"/>
           <p:cNvSpPr txBox="1"/>
           <p:nvPr>
             <p:ph idx="6" type="subTitle"/>
@@ -15296,7 +15170,7 @@
         </p:nvSpPr>
         <p:spPr>
           <a:xfrm>
-            <a:off x="3040588" y="1067825"/>
+            <a:off x="4667575" y="3064175"/>
             <a:ext cx="1261800" cy="458100"/>
           </a:xfrm>
           <a:prstGeom prst="rect">
@@ -15328,7 +15202,7 @@
       </p:sp>
       <p:sp>
         <p:nvSpPr>
-          <p:cNvPr id="133" name="Google Shape;133;p24"/>
+          <p:cNvPr id="127" name="Google Shape;127;p24"/>
           <p:cNvSpPr txBox="1"/>
           <p:nvPr>
             <p:ph idx="1" type="subTitle"/>
@@ -15336,7 +15210,7 @@
         </p:nvSpPr>
         <p:spPr>
           <a:xfrm>
-            <a:off x="3040588" y="1441963"/>
+            <a:off x="4667575" y="3438313"/>
             <a:ext cx="1404600" cy="1555500"/>
           </a:xfrm>
           <a:prstGeom prst="rect">
@@ -15368,7 +15242,7 @@
             </a:r>
             <a:r>
               <a:rPr lang="en"/>
-              <a:t> des del comicili del Cuiner fins al punt de recollida. Rep pagaments. </a:t>
+              <a:t> des del domicili del Cuiner fins al punt de recollida. Rep pagaments. </a:t>
             </a:r>
             <a:endParaRPr/>
           </a:p>
@@ -15376,14 +15250,14 @@
       </p:sp>
       <p:sp>
         <p:nvSpPr>
-          <p:cNvPr id="134" name="Google Shape;134;p24"/>
+          <p:cNvPr id="128" name="Google Shape;128;p24"/>
           <p:cNvSpPr/>
           <p:nvPr/>
         </p:nvSpPr>
         <p:spPr>
           <a:xfrm>
-            <a:off x="3133800" y="3115450"/>
-            <a:ext cx="2876100" cy="1840500"/>
+            <a:off x="1473188" y="894200"/>
+            <a:ext cx="3194400" cy="2013600"/>
           </a:xfrm>
           <a:prstGeom prst="rect">
             <a:avLst/>
@@ -15424,13 +15298,13 @@
       </p:sp>
       <p:sp>
         <p:nvSpPr>
-          <p:cNvPr id="135" name="Google Shape;135;p24"/>
+          <p:cNvPr id="129" name="Google Shape;129;p24"/>
           <p:cNvSpPr/>
           <p:nvPr/>
         </p:nvSpPr>
         <p:spPr>
           <a:xfrm>
-            <a:off x="4639063" y="983813"/>
+            <a:off x="4727200" y="893088"/>
             <a:ext cx="2943300" cy="2013600"/>
           </a:xfrm>
           <a:prstGeom prst="rect">
@@ -15472,7 +15346,7 @@
       </p:sp>
       <p:sp>
         <p:nvSpPr>
-          <p:cNvPr id="136" name="Google Shape;136;p24"/>
+          <p:cNvPr id="130" name="Google Shape;130;p24"/>
           <p:cNvSpPr txBox="1"/>
           <p:nvPr>
             <p:ph idx="2" type="subTitle"/>
@@ -15480,7 +15354,7 @@
         </p:nvSpPr>
         <p:spPr>
           <a:xfrm>
-            <a:off x="6320438" y="1436213"/>
+            <a:off x="6408575" y="1345488"/>
             <a:ext cx="1261800" cy="1463700"/>
           </a:xfrm>
           <a:prstGeom prst="rect">
@@ -15512,7 +15386,7 @@
       </p:sp>
       <p:sp>
         <p:nvSpPr>
-          <p:cNvPr id="137" name="Google Shape;137;p24"/>
+          <p:cNvPr id="131" name="Google Shape;131;p24"/>
           <p:cNvSpPr txBox="1"/>
           <p:nvPr>
             <p:ph idx="7" type="subTitle"/>
@@ -15520,7 +15394,7 @@
         </p:nvSpPr>
         <p:spPr>
           <a:xfrm>
-            <a:off x="6320437" y="1081313"/>
+            <a:off x="6408575" y="990588"/>
             <a:ext cx="1261800" cy="431100"/>
           </a:xfrm>
           <a:prstGeom prst="rect">
@@ -15552,7 +15426,7 @@
       </p:sp>
       <p:sp>
         <p:nvSpPr>
-          <p:cNvPr id="138" name="Google Shape;138;p24"/>
+          <p:cNvPr id="132" name="Google Shape;132;p24"/>
           <p:cNvSpPr txBox="1"/>
           <p:nvPr>
             <p:ph idx="1" type="subTitle"/>
@@ -15560,8 +15434,8 @@
         </p:nvSpPr>
         <p:spPr>
           <a:xfrm>
-            <a:off x="4605116" y="3739768"/>
-            <a:ext cx="1404600" cy="1011300"/>
+            <a:off x="3107297" y="1577236"/>
+            <a:ext cx="1560000" cy="1106400"/>
           </a:xfrm>
           <a:prstGeom prst="rect">
             <a:avLst/>
@@ -15592,7 +15466,7 @@
       </p:sp>
       <p:sp>
         <p:nvSpPr>
-          <p:cNvPr id="139" name="Google Shape;139;p24"/>
+          <p:cNvPr id="133" name="Google Shape;133;p24"/>
           <p:cNvSpPr txBox="1"/>
           <p:nvPr>
             <p:ph idx="5" type="subTitle"/>
@@ -15600,8 +15474,8 @@
         </p:nvSpPr>
         <p:spPr>
           <a:xfrm>
-            <a:off x="4605123" y="3320484"/>
-            <a:ext cx="1404600" cy="509400"/>
+            <a:off x="3107305" y="1118518"/>
+            <a:ext cx="1560000" cy="557400"/>
           </a:xfrm>
           <a:prstGeom prst="rect">
             <a:avLst/>
@@ -15632,7 +15506,7 @@
       </p:sp>
       <p:pic>
         <p:nvPicPr>
-          <p:cNvPr id="140" name="Google Shape;140;p24" title="Recetas de pasta de Karlos Arguiñano _ Web oficial Antena 3.jpg"/>
+          <p:cNvPr id="134" name="Google Shape;134;p24" title="Recetas de pasta de Karlos Arguiñano _ Web oficial Antena 3.jpg"/>
           <p:cNvPicPr preferRelativeResize="0"/>
           <p:nvPr/>
         </p:nvPicPr>
@@ -15645,7 +15519,7 @@
         </p:blipFill>
         <p:spPr>
           <a:xfrm>
-            <a:off x="4739113" y="1070350"/>
+            <a:off x="4827250" y="979625"/>
             <a:ext cx="1495200" cy="1840525"/>
           </a:xfrm>
           <a:prstGeom prst="rect">
@@ -15661,7 +15535,7 @@
       </p:pic>
       <p:pic>
         <p:nvPicPr>
-          <p:cNvPr id="141" name="Google Shape;141;p24" title="meme drôle.jpg"/>
+          <p:cNvPr id="135" name="Google Shape;135;p24" title="meme drôle.jpg"/>
           <p:cNvPicPr preferRelativeResize="0"/>
           <p:nvPr/>
         </p:nvPicPr>
@@ -15674,8 +15548,8 @@
         </p:blipFill>
         <p:spPr>
           <a:xfrm>
-            <a:off x="3276426" y="3224051"/>
-            <a:ext cx="1174426" cy="1623323"/>
+            <a:off x="1631594" y="1013016"/>
+            <a:ext cx="1304370" cy="1775998"/>
           </a:xfrm>
           <a:prstGeom prst="rect">
             <a:avLst/>
@@ -15690,7 +15564,7 @@
       </p:pic>
       <p:pic>
         <p:nvPicPr>
-          <p:cNvPr id="142" name="Google Shape;142;p24" title="Pizza Delivery Man stock image_ Image of smiling, italian - 7741877.jpg"/>
+          <p:cNvPr id="136" name="Google Shape;136;p24" title="Pizza Delivery Man stock image_ Image of smiling, italian - 7741877.jpg"/>
           <p:cNvPicPr preferRelativeResize="0"/>
           <p:nvPr/>
         </p:nvPicPr>
@@ -15703,7 +15577,7 @@
         </p:blipFill>
         <p:spPr>
           <a:xfrm>
-            <a:off x="1659537" y="1073454"/>
+            <a:off x="3286525" y="3069804"/>
             <a:ext cx="1261800" cy="1818446"/>
           </a:xfrm>
           <a:prstGeom prst="rect">
@@ -15728,7 +15602,7 @@
   <p:cSld>
     <p:spTree>
       <p:nvGrpSpPr>
-        <p:cNvPr id="146" name="Shape 146"/>
+        <p:cNvPr id="140" name="Shape 140"/>
         <p:cNvGrpSpPr/>
         <p:nvPr/>
       </p:nvGrpSpPr>
@@ -15742,7 +15616,7 @@
       </p:grpSpPr>
       <p:sp>
         <p:nvSpPr>
-          <p:cNvPr id="147" name="Google Shape;147;p25"/>
+          <p:cNvPr id="141" name="Google Shape;141;p25"/>
           <p:cNvSpPr txBox="1"/>
           <p:nvPr>
             <p:ph type="title"/>
@@ -15782,7 +15656,7 @@
       </p:sp>
       <p:sp>
         <p:nvSpPr>
-          <p:cNvPr id="148" name="Google Shape;148;p25"/>
+          <p:cNvPr id="142" name="Google Shape;142;p25"/>
           <p:cNvSpPr txBox="1"/>
           <p:nvPr/>
         </p:nvSpPr>
@@ -16377,7 +16251,7 @@
   <p:cSld>
     <p:spTree>
       <p:nvGrpSpPr>
-        <p:cNvPr id="152" name="Shape 152"/>
+        <p:cNvPr id="146" name="Shape 146"/>
         <p:cNvGrpSpPr/>
         <p:nvPr/>
       </p:nvGrpSpPr>
@@ -16391,7 +16265,7 @@
       </p:grpSpPr>
       <p:sp>
         <p:nvSpPr>
-          <p:cNvPr id="153" name="Google Shape;153;p26"/>
+          <p:cNvPr id="147" name="Google Shape;147;p26"/>
           <p:cNvSpPr txBox="1"/>
           <p:nvPr>
             <p:ph type="title"/>
@@ -16431,7 +16305,7 @@
       </p:sp>
       <p:sp>
         <p:nvSpPr>
-          <p:cNvPr id="154" name="Google Shape;154;p26"/>
+          <p:cNvPr id="148" name="Google Shape;148;p26"/>
           <p:cNvSpPr txBox="1"/>
           <p:nvPr/>
         </p:nvSpPr>
@@ -17010,7 +16884,7 @@
   <p:cSld>
     <p:spTree>
       <p:nvGrpSpPr>
-        <p:cNvPr id="158" name="Shape 158"/>
+        <p:cNvPr id="152" name="Shape 152"/>
         <p:cNvGrpSpPr/>
         <p:nvPr/>
       </p:nvGrpSpPr>
@@ -17024,7 +16898,7 @@
       </p:grpSpPr>
       <p:sp>
         <p:nvSpPr>
-          <p:cNvPr id="159" name="Google Shape;159;p27"/>
+          <p:cNvPr id="153" name="Google Shape;153;p27"/>
           <p:cNvSpPr txBox="1"/>
           <p:nvPr>
             <p:ph type="title"/>
@@ -17064,7 +16938,7 @@
       </p:sp>
       <p:sp>
         <p:nvSpPr>
-          <p:cNvPr id="160" name="Google Shape;160;p27"/>
+          <p:cNvPr id="154" name="Google Shape;154;p27"/>
           <p:cNvSpPr txBox="1"/>
           <p:nvPr/>
         </p:nvSpPr>
@@ -17382,7 +17256,7 @@
   <p:cSld>
     <p:spTree>
       <p:nvGrpSpPr>
-        <p:cNvPr id="164" name="Shape 164"/>
+        <p:cNvPr id="158" name="Shape 158"/>
         <p:cNvGrpSpPr/>
         <p:nvPr/>
       </p:nvGrpSpPr>
@@ -17396,7 +17270,7 @@
       </p:grpSpPr>
       <p:sp>
         <p:nvSpPr>
-          <p:cNvPr id="165" name="Google Shape;165;p28"/>
+          <p:cNvPr id="159" name="Google Shape;159;p28"/>
           <p:cNvSpPr txBox="1"/>
           <p:nvPr>
             <p:ph type="title"/>
@@ -17436,7 +17310,7 @@
       </p:sp>
       <p:sp>
         <p:nvSpPr>
-          <p:cNvPr id="166" name="Google Shape;166;p28"/>
+          <p:cNvPr id="160" name="Google Shape;160;p28"/>
           <p:cNvSpPr txBox="1"/>
           <p:nvPr/>
         </p:nvSpPr>
@@ -17730,7 +17604,7 @@
   <p:cSld>
     <p:spTree>
       <p:nvGrpSpPr>
-        <p:cNvPr id="170" name="Shape 170"/>
+        <p:cNvPr id="164" name="Shape 164"/>
         <p:cNvGrpSpPr/>
         <p:nvPr/>
       </p:nvGrpSpPr>
@@ -17744,7 +17618,7 @@
       </p:grpSpPr>
       <p:sp>
         <p:nvSpPr>
-          <p:cNvPr id="171" name="Google Shape;171;p29"/>
+          <p:cNvPr id="165" name="Google Shape;165;p29"/>
           <p:cNvSpPr txBox="1"/>
           <p:nvPr>
             <p:ph type="title"/>
@@ -17784,7 +17658,7 @@
       </p:sp>
       <p:sp>
         <p:nvSpPr>
-          <p:cNvPr id="172" name="Google Shape;172;p29"/>
+          <p:cNvPr id="166" name="Google Shape;166;p29"/>
           <p:cNvSpPr txBox="1"/>
           <p:nvPr/>
         </p:nvSpPr>

</xml_diff>